<commit_message>
Fixed the wrong buffer from ARRAY to ELEMENT on the index buffer load
</commit_message>
<xml_diff>
--- a/Lectures/Day_02/Pipeline.pptx
+++ b/Lectures/Day_02/Pipeline.pptx
@@ -6,6 +6,10 @@
   </p:sldMasterIdLst>
   <p:sldIdLst>
     <p:sldId id="256" r:id="rId2"/>
+    <p:sldId id="257" r:id="rId3"/>
+    <p:sldId id="258" r:id="rId4"/>
+    <p:sldId id="259" r:id="rId5"/>
+    <p:sldId id="260" r:id="rId6"/>
   </p:sldIdLst>
   <p:sldSz cx="12192000" cy="6858000"/>
   <p:notesSz cx="6858000" cy="9144000"/>
@@ -104,6 +108,11 @@
       </a:defRPr>
     </a:lvl9pPr>
   </p:defaultTextStyle>
+  <p:extLst>
+    <p:ext uri="{EFAFB233-063F-42B5-8137-9DF3F51BA10A}">
+      <p15:sldGuideLst xmlns:p15="http://schemas.microsoft.com/office/powerpoint/2012/main"/>
+    </p:ext>
+  </p:extLst>
 </p:presentation>
 </file>
 
@@ -256,7 +265,7 @@
           <a:p>
             <a:fld id="{6B531558-3E01-439E-B6E2-7853B2E97E21}" type="datetimeFigureOut">
               <a:rPr lang="en-CA" smtClean="0"/>
-              <a:t>2026-05-13</a:t>
+              <a:t>2026-05-20</a:t>
             </a:fld>
             <a:endParaRPr lang="en-CA"/>
           </a:p>
@@ -456,7 +465,7 @@
           <a:p>
             <a:fld id="{6B531558-3E01-439E-B6E2-7853B2E97E21}" type="datetimeFigureOut">
               <a:rPr lang="en-CA" smtClean="0"/>
-              <a:t>2026-05-13</a:t>
+              <a:t>2026-05-20</a:t>
             </a:fld>
             <a:endParaRPr lang="en-CA"/>
           </a:p>
@@ -666,7 +675,7 @@
           <a:p>
             <a:fld id="{6B531558-3E01-439E-B6E2-7853B2E97E21}" type="datetimeFigureOut">
               <a:rPr lang="en-CA" smtClean="0"/>
-              <a:t>2026-05-13</a:t>
+              <a:t>2026-05-20</a:t>
             </a:fld>
             <a:endParaRPr lang="en-CA"/>
           </a:p>
@@ -866,7 +875,7 @@
           <a:p>
             <a:fld id="{6B531558-3E01-439E-B6E2-7853B2E97E21}" type="datetimeFigureOut">
               <a:rPr lang="en-CA" smtClean="0"/>
-              <a:t>2026-05-13</a:t>
+              <a:t>2026-05-20</a:t>
             </a:fld>
             <a:endParaRPr lang="en-CA"/>
           </a:p>
@@ -1142,7 +1151,7 @@
           <a:p>
             <a:fld id="{6B531558-3E01-439E-B6E2-7853B2E97E21}" type="datetimeFigureOut">
               <a:rPr lang="en-CA" smtClean="0"/>
-              <a:t>2026-05-13</a:t>
+              <a:t>2026-05-20</a:t>
             </a:fld>
             <a:endParaRPr lang="en-CA"/>
           </a:p>
@@ -1410,7 +1419,7 @@
           <a:p>
             <a:fld id="{6B531558-3E01-439E-B6E2-7853B2E97E21}" type="datetimeFigureOut">
               <a:rPr lang="en-CA" smtClean="0"/>
-              <a:t>2026-05-13</a:t>
+              <a:t>2026-05-20</a:t>
             </a:fld>
             <a:endParaRPr lang="en-CA"/>
           </a:p>
@@ -1825,7 +1834,7 @@
           <a:p>
             <a:fld id="{6B531558-3E01-439E-B6E2-7853B2E97E21}" type="datetimeFigureOut">
               <a:rPr lang="en-CA" smtClean="0"/>
-              <a:t>2026-05-13</a:t>
+              <a:t>2026-05-20</a:t>
             </a:fld>
             <a:endParaRPr lang="en-CA"/>
           </a:p>
@@ -1967,7 +1976,7 @@
           <a:p>
             <a:fld id="{6B531558-3E01-439E-B6E2-7853B2E97E21}" type="datetimeFigureOut">
               <a:rPr lang="en-CA" smtClean="0"/>
-              <a:t>2026-05-13</a:t>
+              <a:t>2026-05-20</a:t>
             </a:fld>
             <a:endParaRPr lang="en-CA"/>
           </a:p>
@@ -2080,7 +2089,7 @@
           <a:p>
             <a:fld id="{6B531558-3E01-439E-B6E2-7853B2E97E21}" type="datetimeFigureOut">
               <a:rPr lang="en-CA" smtClean="0"/>
-              <a:t>2026-05-13</a:t>
+              <a:t>2026-05-20</a:t>
             </a:fld>
             <a:endParaRPr lang="en-CA"/>
           </a:p>
@@ -2393,7 +2402,7 @@
           <a:p>
             <a:fld id="{6B531558-3E01-439E-B6E2-7853B2E97E21}" type="datetimeFigureOut">
               <a:rPr lang="en-CA" smtClean="0"/>
-              <a:t>2026-05-13</a:t>
+              <a:t>2026-05-20</a:t>
             </a:fld>
             <a:endParaRPr lang="en-CA"/>
           </a:p>
@@ -2682,7 +2691,7 @@
           <a:p>
             <a:fld id="{6B531558-3E01-439E-B6E2-7853B2E97E21}" type="datetimeFigureOut">
               <a:rPr lang="en-CA" smtClean="0"/>
-              <a:t>2026-05-13</a:t>
+              <a:t>2026-05-20</a:t>
             </a:fld>
             <a:endParaRPr lang="en-CA"/>
           </a:p>
@@ -2925,7 +2934,7 @@
           <a:p>
             <a:fld id="{6B531558-3E01-439E-B6E2-7853B2E97E21}" type="datetimeFigureOut">
               <a:rPr lang="en-CA" smtClean="0"/>
-              <a:t>2026-05-13</a:t>
+              <a:t>2026-05-20</a:t>
             </a:fld>
             <a:endParaRPr lang="en-CA"/>
           </a:p>
@@ -3473,7 +3482,7 @@
         </p:nvSpPr>
         <p:spPr>
           <a:xfrm>
-            <a:off x="4041061" y="1487131"/>
+            <a:off x="3165378" y="1487131"/>
             <a:ext cx="669819" cy="3962400"/>
           </a:xfrm>
           <a:prstGeom prst="rect">
@@ -3691,8 +3700,8 @@
         </p:nvSpPr>
         <p:spPr>
           <a:xfrm>
-            <a:off x="4768646" y="2998839"/>
-            <a:ext cx="1499418" cy="1219200"/>
+            <a:off x="4100667" y="2998839"/>
+            <a:ext cx="2167397" cy="1219200"/>
           </a:xfrm>
           <a:prstGeom prst="rightArrow">
             <a:avLst/>
@@ -3969,8 +3978,8 @@
         </p:nvSpPr>
         <p:spPr>
           <a:xfrm>
-            <a:off x="7911283" y="2858731"/>
-            <a:ext cx="1364227" cy="1219200"/>
+            <a:off x="7492181" y="2858731"/>
+            <a:ext cx="1783330" cy="1219200"/>
           </a:xfrm>
           <a:prstGeom prst="rightArrow">
             <a:avLst/>
@@ -4090,12 +4099,42 @@
           </a:p>
         </p:txBody>
       </p:sp>
-      <p:sp>
-        <p:nvSpPr>
-          <p:cNvPr id="16" name="Rectangle 15">
-            <a:extLst>
-              <a:ext uri="{FF2B5EF4-FFF2-40B4-BE49-F238E27FC236}">
-                <a16:creationId xmlns:a16="http://schemas.microsoft.com/office/drawing/2014/main" id="{AE5473DE-6B16-9DD1-C107-558517EF26D8}"/>
+    </p:spTree>
+    <p:extLst>
+      <p:ext uri="{BB962C8B-B14F-4D97-AF65-F5344CB8AC3E}">
+        <p14:creationId xmlns:p14="http://schemas.microsoft.com/office/powerpoint/2010/main" val="800627848"/>
+      </p:ext>
+    </p:extLst>
+  </p:cSld>
+  <p:clrMapOvr>
+    <a:masterClrMapping/>
+  </p:clrMapOvr>
+</p:sld>
+</file>
+
+<file path=ppt/slides/slide2.xml><?xml version="1.0" encoding="utf-8"?>
+<p:sld xmlns:a="http://schemas.openxmlformats.org/drawingml/2006/main" xmlns:r="http://schemas.openxmlformats.org/officeDocument/2006/relationships" xmlns:p="http://schemas.openxmlformats.org/presentationml/2006/main">
+  <p:cSld>
+    <p:spTree>
+      <p:nvGrpSpPr>
+        <p:cNvPr id="1" name=""/>
+        <p:cNvGrpSpPr/>
+        <p:nvPr/>
+      </p:nvGrpSpPr>
+      <p:grpSpPr>
+        <a:xfrm>
+          <a:off x="0" y="0"/>
+          <a:ext cx="0" cy="0"/>
+          <a:chOff x="0" y="0"/>
+          <a:chExt cx="0" cy="0"/>
+        </a:xfrm>
+      </p:grpSpPr>
+      <p:sp>
+        <p:nvSpPr>
+          <p:cNvPr id="5" name="Rectangle: Rounded Corners 4">
+            <a:extLst>
+              <a:ext uri="{FF2B5EF4-FFF2-40B4-BE49-F238E27FC236}">
+                <a16:creationId xmlns:a16="http://schemas.microsoft.com/office/drawing/2014/main" id="{855FD758-8CA8-97F0-86A6-673795C8D55E}"/>
               </a:ext>
             </a:extLst>
           </p:cNvPr>
@@ -4104,8 +4143,125 @@
         </p:nvSpPr>
         <p:spPr>
           <a:xfrm>
-            <a:off x="7497100" y="1622323"/>
-            <a:ext cx="929146" cy="3962400"/>
+            <a:off x="2359742" y="88490"/>
+            <a:ext cx="2756715" cy="6459794"/>
+          </a:xfrm>
+          <a:prstGeom prst="roundRect">
+            <a:avLst/>
+          </a:prstGeom>
+        </p:spPr>
+        <p:style>
+          <a:lnRef idx="2">
+            <a:schemeClr val="accent1">
+              <a:shade val="15000"/>
+            </a:schemeClr>
+          </a:lnRef>
+          <a:fillRef idx="1">
+            <a:schemeClr val="accent1"/>
+          </a:fillRef>
+          <a:effectRef idx="0">
+            <a:schemeClr val="accent1"/>
+          </a:effectRef>
+          <a:fontRef idx="minor">
+            <a:schemeClr val="lt1"/>
+          </a:fontRef>
+        </p:style>
+        <p:txBody>
+          <a:bodyPr rtlCol="0" anchor="ctr"/>
+          <a:lstStyle/>
+          <a:p>
+            <a:pPr algn="ctr"/>
+            <a:r>
+              <a:rPr lang="en-CA" dirty="0"/>
+              <a:t>CPU (C++)</a:t>
+            </a:r>
+          </a:p>
+          <a:p>
+            <a:pPr algn="ctr"/>
+            <a:endParaRPr lang="en-CA" dirty="0"/>
+          </a:p>
+          <a:p>
+            <a:pPr algn="ctr"/>
+            <a:endParaRPr lang="en-CA" dirty="0"/>
+          </a:p>
+          <a:p>
+            <a:pPr algn="ctr"/>
+            <a:endParaRPr lang="en-CA" dirty="0"/>
+          </a:p>
+          <a:p>
+            <a:pPr algn="ctr"/>
+            <a:endParaRPr lang="en-CA" dirty="0"/>
+          </a:p>
+          <a:p>
+            <a:pPr algn="ctr"/>
+            <a:endParaRPr lang="en-CA" dirty="0"/>
+          </a:p>
+          <a:p>
+            <a:pPr algn="ctr"/>
+            <a:endParaRPr lang="en-CA" dirty="0"/>
+          </a:p>
+          <a:p>
+            <a:pPr algn="ctr"/>
+            <a:endParaRPr lang="en-CA" dirty="0"/>
+          </a:p>
+          <a:p>
+            <a:pPr algn="ctr"/>
+            <a:endParaRPr lang="en-CA" dirty="0"/>
+          </a:p>
+          <a:p>
+            <a:pPr algn="ctr"/>
+            <a:endParaRPr lang="en-CA" dirty="0"/>
+          </a:p>
+          <a:p>
+            <a:pPr algn="ctr"/>
+            <a:endParaRPr lang="en-CA" dirty="0"/>
+          </a:p>
+          <a:p>
+            <a:pPr algn="ctr"/>
+            <a:endParaRPr lang="en-CA" dirty="0"/>
+          </a:p>
+          <a:p>
+            <a:pPr algn="ctr"/>
+            <a:endParaRPr lang="en-CA" dirty="0"/>
+          </a:p>
+          <a:p>
+            <a:pPr algn="ctr"/>
+            <a:endParaRPr lang="en-CA" dirty="0"/>
+          </a:p>
+          <a:p>
+            <a:pPr algn="ctr"/>
+            <a:endParaRPr lang="en-CA" dirty="0"/>
+          </a:p>
+          <a:p>
+            <a:pPr algn="ctr"/>
+            <a:endParaRPr lang="en-CA" dirty="0"/>
+          </a:p>
+          <a:p>
+            <a:pPr algn="ctr"/>
+            <a:endParaRPr lang="en-CA" dirty="0"/>
+          </a:p>
+          <a:p>
+            <a:pPr algn="ctr"/>
+            <a:endParaRPr lang="en-CA" dirty="0"/>
+          </a:p>
+        </p:txBody>
+      </p:sp>
+      <p:sp>
+        <p:nvSpPr>
+          <p:cNvPr id="4" name="Rectangle 3">
+            <a:extLst>
+              <a:ext uri="{FF2B5EF4-FFF2-40B4-BE49-F238E27FC236}">
+                <a16:creationId xmlns:a16="http://schemas.microsoft.com/office/drawing/2014/main" id="{9A6E1664-BDE9-C8D9-CFE3-3745CB0CEEB5}"/>
+              </a:ext>
+            </a:extLst>
+          </p:cNvPr>
+          <p:cNvSpPr/>
+          <p:nvPr/>
+        </p:nvSpPr>
+        <p:spPr>
+          <a:xfrm>
+            <a:off x="4080392" y="1447800"/>
+            <a:ext cx="669819" cy="3962400"/>
           </a:xfrm>
           <a:prstGeom prst="rect">
             <a:avLst/>
@@ -4132,24 +4288,17 @@
             <a:pPr algn="ctr"/>
             <a:r>
               <a:rPr lang="en-CA" dirty="0"/>
-              <a:t>Index</a:t>
-            </a:r>
-          </a:p>
-          <a:p>
-            <a:pPr algn="ctr"/>
-            <a:r>
-              <a:rPr lang="en-CA" dirty="0"/>
-              <a:t>buffer</a:t>
-            </a:r>
-          </a:p>
-        </p:txBody>
-      </p:sp>
-      <p:sp>
-        <p:nvSpPr>
-          <p:cNvPr id="17" name="Rectangle 16">
-            <a:extLst>
-              <a:ext uri="{FF2B5EF4-FFF2-40B4-BE49-F238E27FC236}">
-                <a16:creationId xmlns:a16="http://schemas.microsoft.com/office/drawing/2014/main" id="{07BFFAB9-075E-CEEE-81DF-E3C0EF4A7A6A}"/>
+              <a:t>RAM</a:t>
+            </a:r>
+          </a:p>
+        </p:txBody>
+      </p:sp>
+      <p:sp>
+        <p:nvSpPr>
+          <p:cNvPr id="6" name="Rectangle: Rounded Corners 5">
+            <a:extLst>
+              <a:ext uri="{FF2B5EF4-FFF2-40B4-BE49-F238E27FC236}">
+                <a16:creationId xmlns:a16="http://schemas.microsoft.com/office/drawing/2014/main" id="{A7AB6A8E-617B-EFE7-82EB-41E6C14BB692}"/>
               </a:ext>
             </a:extLst>
           </p:cNvPr>
@@ -4158,8 +4307,125 @@
         </p:nvSpPr>
         <p:spPr>
           <a:xfrm>
-            <a:off x="2703879" y="1487131"/>
-            <a:ext cx="796409" cy="1619864"/>
+            <a:off x="5830530" y="88490"/>
+            <a:ext cx="5309418" cy="6459794"/>
+          </a:xfrm>
+          <a:prstGeom prst="roundRect">
+            <a:avLst/>
+          </a:prstGeom>
+        </p:spPr>
+        <p:style>
+          <a:lnRef idx="2">
+            <a:schemeClr val="accent1">
+              <a:shade val="15000"/>
+            </a:schemeClr>
+          </a:lnRef>
+          <a:fillRef idx="1">
+            <a:schemeClr val="accent1"/>
+          </a:fillRef>
+          <a:effectRef idx="0">
+            <a:schemeClr val="accent1"/>
+          </a:effectRef>
+          <a:fontRef idx="minor">
+            <a:schemeClr val="lt1"/>
+          </a:fontRef>
+        </p:style>
+        <p:txBody>
+          <a:bodyPr rtlCol="0" anchor="ctr"/>
+          <a:lstStyle/>
+          <a:p>
+            <a:pPr algn="ctr"/>
+            <a:r>
+              <a:rPr lang="en-CA" dirty="0"/>
+              <a:t>GPU</a:t>
+            </a:r>
+          </a:p>
+          <a:p>
+            <a:pPr algn="ctr"/>
+            <a:endParaRPr lang="en-CA" dirty="0"/>
+          </a:p>
+          <a:p>
+            <a:pPr algn="ctr"/>
+            <a:endParaRPr lang="en-CA" dirty="0"/>
+          </a:p>
+          <a:p>
+            <a:pPr algn="ctr"/>
+            <a:endParaRPr lang="en-CA" dirty="0"/>
+          </a:p>
+          <a:p>
+            <a:pPr algn="ctr"/>
+            <a:endParaRPr lang="en-CA" dirty="0"/>
+          </a:p>
+          <a:p>
+            <a:pPr algn="ctr"/>
+            <a:endParaRPr lang="en-CA" dirty="0"/>
+          </a:p>
+          <a:p>
+            <a:pPr algn="ctr"/>
+            <a:endParaRPr lang="en-CA" dirty="0"/>
+          </a:p>
+          <a:p>
+            <a:pPr algn="ctr"/>
+            <a:endParaRPr lang="en-CA" dirty="0"/>
+          </a:p>
+          <a:p>
+            <a:pPr algn="ctr"/>
+            <a:endParaRPr lang="en-CA" dirty="0"/>
+          </a:p>
+          <a:p>
+            <a:pPr algn="ctr"/>
+            <a:endParaRPr lang="en-CA" dirty="0"/>
+          </a:p>
+          <a:p>
+            <a:pPr algn="ctr"/>
+            <a:endParaRPr lang="en-CA" dirty="0"/>
+          </a:p>
+          <a:p>
+            <a:pPr algn="ctr"/>
+            <a:endParaRPr lang="en-CA" dirty="0"/>
+          </a:p>
+          <a:p>
+            <a:pPr algn="ctr"/>
+            <a:endParaRPr lang="en-CA" dirty="0"/>
+          </a:p>
+          <a:p>
+            <a:pPr algn="ctr"/>
+            <a:endParaRPr lang="en-CA" dirty="0"/>
+          </a:p>
+          <a:p>
+            <a:pPr algn="ctr"/>
+            <a:endParaRPr lang="en-CA" dirty="0"/>
+          </a:p>
+          <a:p>
+            <a:pPr algn="ctr"/>
+            <a:endParaRPr lang="en-CA" dirty="0"/>
+          </a:p>
+          <a:p>
+            <a:pPr algn="ctr"/>
+            <a:endParaRPr lang="en-CA" dirty="0"/>
+          </a:p>
+          <a:p>
+            <a:pPr algn="ctr"/>
+            <a:endParaRPr lang="en-CA" dirty="0"/>
+          </a:p>
+        </p:txBody>
+      </p:sp>
+      <p:sp>
+        <p:nvSpPr>
+          <p:cNvPr id="7" name="Rectangle 6">
+            <a:extLst>
+              <a:ext uri="{FF2B5EF4-FFF2-40B4-BE49-F238E27FC236}">
+                <a16:creationId xmlns:a16="http://schemas.microsoft.com/office/drawing/2014/main" id="{A0A7DBA7-1C8E-1277-B21A-295B2BF3A4E4}"/>
+              </a:ext>
+            </a:extLst>
+          </p:cNvPr>
+          <p:cNvSpPr/>
+          <p:nvPr/>
+        </p:nvSpPr>
+        <p:spPr>
+          <a:xfrm>
+            <a:off x="7027611" y="1447800"/>
+            <a:ext cx="929146" cy="3962400"/>
           </a:xfrm>
           <a:prstGeom prst="rect">
             <a:avLst/>
@@ -4186,17 +4452,24 @@
             <a:pPr algn="ctr"/>
             <a:r>
               <a:rPr lang="en-CA" dirty="0"/>
-              <a:t>RAM</a:t>
-            </a:r>
-          </a:p>
-        </p:txBody>
-      </p:sp>
-      <p:sp>
-        <p:nvSpPr>
-          <p:cNvPr id="18" name="Rectangle 17">
-            <a:extLst>
-              <a:ext uri="{FF2B5EF4-FFF2-40B4-BE49-F238E27FC236}">
-                <a16:creationId xmlns:a16="http://schemas.microsoft.com/office/drawing/2014/main" id="{BC83CAE1-9ED2-50EE-1550-D6F02FA2158D}"/>
+              <a:t>Vertex</a:t>
+            </a:r>
+          </a:p>
+          <a:p>
+            <a:pPr algn="ctr"/>
+            <a:r>
+              <a:rPr lang="en-CA" dirty="0"/>
+              <a:t>buffer</a:t>
+            </a:r>
+          </a:p>
+        </p:txBody>
+      </p:sp>
+      <p:sp>
+        <p:nvSpPr>
+          <p:cNvPr id="8" name="Arrow: Right 7">
+            <a:extLst>
+              <a:ext uri="{FF2B5EF4-FFF2-40B4-BE49-F238E27FC236}">
+                <a16:creationId xmlns:a16="http://schemas.microsoft.com/office/drawing/2014/main" id="{9E9D5935-7A52-C77B-8374-E864BCEE7462}"/>
               </a:ext>
             </a:extLst>
           </p:cNvPr>
@@ -4205,8 +4478,330 @@
         </p:nvSpPr>
         <p:spPr>
           <a:xfrm>
-            <a:off x="2674379" y="3298724"/>
-            <a:ext cx="796409" cy="1619864"/>
+            <a:off x="4823339" y="2885769"/>
+            <a:ext cx="2014381" cy="1219200"/>
+          </a:xfrm>
+          <a:prstGeom prst="rightArrow">
+            <a:avLst/>
+          </a:prstGeom>
+        </p:spPr>
+        <p:style>
+          <a:lnRef idx="1">
+            <a:schemeClr val="accent2"/>
+          </a:lnRef>
+          <a:fillRef idx="3">
+            <a:schemeClr val="accent2"/>
+          </a:fillRef>
+          <a:effectRef idx="2">
+            <a:schemeClr val="accent2"/>
+          </a:effectRef>
+          <a:fontRef idx="minor">
+            <a:schemeClr val="lt1"/>
+          </a:fontRef>
+        </p:style>
+        <p:txBody>
+          <a:bodyPr rtlCol="0" anchor="ctr"/>
+          <a:lstStyle/>
+          <a:p>
+            <a:pPr algn="ctr"/>
+            <a:endParaRPr lang="en-CA"/>
+          </a:p>
+        </p:txBody>
+      </p:sp>
+      <p:sp>
+        <p:nvSpPr>
+          <p:cNvPr id="11" name="Rectangle: Rounded Corners 10">
+            <a:extLst>
+              <a:ext uri="{FF2B5EF4-FFF2-40B4-BE49-F238E27FC236}">
+                <a16:creationId xmlns:a16="http://schemas.microsoft.com/office/drawing/2014/main" id="{DD8208FC-83C2-3DB4-987C-E51904197546}"/>
+              </a:ext>
+            </a:extLst>
+          </p:cNvPr>
+          <p:cNvSpPr/>
+          <p:nvPr/>
+        </p:nvSpPr>
+        <p:spPr>
+          <a:xfrm>
+            <a:off x="8554065" y="1622323"/>
+            <a:ext cx="2792361" cy="2969343"/>
+          </a:xfrm>
+          <a:prstGeom prst="roundRect">
+            <a:avLst/>
+          </a:prstGeom>
+        </p:spPr>
+        <p:style>
+          <a:lnRef idx="2">
+            <a:schemeClr val="accent1">
+              <a:shade val="15000"/>
+            </a:schemeClr>
+          </a:lnRef>
+          <a:fillRef idx="1">
+            <a:schemeClr val="accent1"/>
+          </a:fillRef>
+          <a:effectRef idx="0">
+            <a:schemeClr val="accent1"/>
+          </a:effectRef>
+          <a:fontRef idx="minor">
+            <a:schemeClr val="lt1"/>
+          </a:fontRef>
+        </p:style>
+        <p:txBody>
+          <a:bodyPr rtlCol="0" anchor="ctr"/>
+          <a:lstStyle/>
+          <a:p>
+            <a:pPr algn="ctr"/>
+            <a:r>
+              <a:rPr lang="en-CA" dirty="0"/>
+              <a:t>Shader “Program”</a:t>
+            </a:r>
+          </a:p>
+          <a:p>
+            <a:pPr algn="ctr"/>
+            <a:endParaRPr lang="en-CA" dirty="0"/>
+          </a:p>
+          <a:p>
+            <a:pPr algn="ctr"/>
+            <a:endParaRPr lang="en-CA" dirty="0"/>
+          </a:p>
+          <a:p>
+            <a:pPr algn="ctr"/>
+            <a:endParaRPr lang="en-CA" dirty="0"/>
+          </a:p>
+          <a:p>
+            <a:pPr algn="ctr"/>
+            <a:endParaRPr lang="en-CA" dirty="0"/>
+          </a:p>
+          <a:p>
+            <a:pPr algn="ctr"/>
+            <a:endParaRPr lang="en-CA" dirty="0"/>
+          </a:p>
+          <a:p>
+            <a:pPr algn="ctr"/>
+            <a:endParaRPr lang="en-CA" dirty="0"/>
+          </a:p>
+          <a:p>
+            <a:pPr algn="ctr"/>
+            <a:endParaRPr lang="en-CA" dirty="0"/>
+          </a:p>
+          <a:p>
+            <a:pPr algn="ctr"/>
+            <a:endParaRPr lang="en-CA" dirty="0"/>
+          </a:p>
+          <a:p>
+            <a:pPr algn="ctr"/>
+            <a:endParaRPr lang="en-CA" dirty="0"/>
+          </a:p>
+        </p:txBody>
+      </p:sp>
+      <p:sp>
+        <p:nvSpPr>
+          <p:cNvPr id="9" name="Rectangle: Rounded Corners 8">
+            <a:extLst>
+              <a:ext uri="{FF2B5EF4-FFF2-40B4-BE49-F238E27FC236}">
+                <a16:creationId xmlns:a16="http://schemas.microsoft.com/office/drawing/2014/main" id="{C770166A-DA62-5E5D-EC57-615034048C5E}"/>
+              </a:ext>
+            </a:extLst>
+          </p:cNvPr>
+          <p:cNvSpPr/>
+          <p:nvPr/>
+        </p:nvSpPr>
+        <p:spPr>
+          <a:xfrm>
+            <a:off x="9026013" y="2271253"/>
+            <a:ext cx="1986116" cy="835742"/>
+          </a:xfrm>
+          <a:prstGeom prst="roundRect">
+            <a:avLst/>
+          </a:prstGeom>
+        </p:spPr>
+        <p:style>
+          <a:lnRef idx="3">
+            <a:schemeClr val="lt1"/>
+          </a:lnRef>
+          <a:fillRef idx="1">
+            <a:schemeClr val="accent4"/>
+          </a:fillRef>
+          <a:effectRef idx="1">
+            <a:schemeClr val="accent4"/>
+          </a:effectRef>
+          <a:fontRef idx="minor">
+            <a:schemeClr val="lt1"/>
+          </a:fontRef>
+        </p:style>
+        <p:txBody>
+          <a:bodyPr rtlCol="0" anchor="ctr"/>
+          <a:lstStyle/>
+          <a:p>
+            <a:pPr algn="ctr"/>
+            <a:r>
+              <a:rPr lang="en-CA" dirty="0">
+                <a:solidFill>
+                  <a:schemeClr val="tx1"/>
+                </a:solidFill>
+              </a:rPr>
+              <a:t>Vertex</a:t>
+            </a:r>
+          </a:p>
+        </p:txBody>
+      </p:sp>
+      <p:sp>
+        <p:nvSpPr>
+          <p:cNvPr id="10" name="Rectangle: Rounded Corners 9">
+            <a:extLst>
+              <a:ext uri="{FF2B5EF4-FFF2-40B4-BE49-F238E27FC236}">
+                <a16:creationId xmlns:a16="http://schemas.microsoft.com/office/drawing/2014/main" id="{F55A8CC1-47C2-1E03-2710-00949FBA61EF}"/>
+              </a:ext>
+            </a:extLst>
+          </p:cNvPr>
+          <p:cNvSpPr/>
+          <p:nvPr/>
+        </p:nvSpPr>
+        <p:spPr>
+          <a:xfrm>
+            <a:off x="9026013" y="3298724"/>
+            <a:ext cx="1986116" cy="835742"/>
+          </a:xfrm>
+          <a:prstGeom prst="roundRect">
+            <a:avLst/>
+          </a:prstGeom>
+        </p:spPr>
+        <p:style>
+          <a:lnRef idx="3">
+            <a:schemeClr val="lt1"/>
+          </a:lnRef>
+          <a:fillRef idx="1">
+            <a:schemeClr val="accent4"/>
+          </a:fillRef>
+          <a:effectRef idx="1">
+            <a:schemeClr val="accent4"/>
+          </a:effectRef>
+          <a:fontRef idx="minor">
+            <a:schemeClr val="lt1"/>
+          </a:fontRef>
+        </p:style>
+        <p:txBody>
+          <a:bodyPr rtlCol="0" anchor="ctr"/>
+          <a:lstStyle/>
+          <a:p>
+            <a:pPr algn="ctr"/>
+            <a:r>
+              <a:rPr lang="en-CA" dirty="0">
+                <a:solidFill>
+                  <a:schemeClr val="tx1"/>
+                </a:solidFill>
+              </a:rPr>
+              <a:t>Fragment</a:t>
+            </a:r>
+          </a:p>
+        </p:txBody>
+      </p:sp>
+      <p:sp>
+        <p:nvSpPr>
+          <p:cNvPr id="12" name="Arrow: Right 11">
+            <a:extLst>
+              <a:ext uri="{FF2B5EF4-FFF2-40B4-BE49-F238E27FC236}">
+                <a16:creationId xmlns:a16="http://schemas.microsoft.com/office/drawing/2014/main" id="{A94E4D52-A290-E5D3-0494-1F5571B038C3}"/>
+              </a:ext>
+            </a:extLst>
+          </p:cNvPr>
+          <p:cNvSpPr/>
+          <p:nvPr/>
+        </p:nvSpPr>
+        <p:spPr>
+          <a:xfrm>
+            <a:off x="11611896" y="2571136"/>
+            <a:ext cx="2261420" cy="1219200"/>
+          </a:xfrm>
+          <a:prstGeom prst="rightArrow">
+            <a:avLst/>
+          </a:prstGeom>
+        </p:spPr>
+        <p:style>
+          <a:lnRef idx="1">
+            <a:schemeClr val="accent2"/>
+          </a:lnRef>
+          <a:fillRef idx="3">
+            <a:schemeClr val="accent2"/>
+          </a:fillRef>
+          <a:effectRef idx="2">
+            <a:schemeClr val="accent2"/>
+          </a:effectRef>
+          <a:fontRef idx="minor">
+            <a:schemeClr val="lt1"/>
+          </a:fontRef>
+        </p:style>
+        <p:txBody>
+          <a:bodyPr rtlCol="0" anchor="ctr"/>
+          <a:lstStyle/>
+          <a:p>
+            <a:pPr algn="ctr"/>
+            <a:r>
+              <a:rPr lang="en-CA" dirty="0"/>
+              <a:t>To the screen (back buffer)</a:t>
+            </a:r>
+          </a:p>
+        </p:txBody>
+      </p:sp>
+      <p:sp>
+        <p:nvSpPr>
+          <p:cNvPr id="13" name="Arrow: Right 12">
+            <a:extLst>
+              <a:ext uri="{FF2B5EF4-FFF2-40B4-BE49-F238E27FC236}">
+                <a16:creationId xmlns:a16="http://schemas.microsoft.com/office/drawing/2014/main" id="{5F240329-D1AC-2AA6-9E5F-9F28FBD8DB21}"/>
+              </a:ext>
+            </a:extLst>
+          </p:cNvPr>
+          <p:cNvSpPr/>
+          <p:nvPr/>
+        </p:nvSpPr>
+        <p:spPr>
+          <a:xfrm>
+            <a:off x="7911283" y="2858731"/>
+            <a:ext cx="1364227" cy="1219200"/>
+          </a:xfrm>
+          <a:prstGeom prst="rightArrow">
+            <a:avLst/>
+          </a:prstGeom>
+        </p:spPr>
+        <p:style>
+          <a:lnRef idx="1">
+            <a:schemeClr val="accent2"/>
+          </a:lnRef>
+          <a:fillRef idx="3">
+            <a:schemeClr val="accent2"/>
+          </a:fillRef>
+          <a:effectRef idx="2">
+            <a:schemeClr val="accent2"/>
+          </a:effectRef>
+          <a:fontRef idx="minor">
+            <a:schemeClr val="lt1"/>
+          </a:fontRef>
+        </p:style>
+        <p:txBody>
+          <a:bodyPr rtlCol="0" anchor="ctr"/>
+          <a:lstStyle/>
+          <a:p>
+            <a:pPr algn="ctr"/>
+            <a:endParaRPr lang="en-CA"/>
+          </a:p>
+        </p:txBody>
+      </p:sp>
+      <p:sp>
+        <p:nvSpPr>
+          <p:cNvPr id="14" name="Rectangle 13">
+            <a:extLst>
+              <a:ext uri="{FF2B5EF4-FFF2-40B4-BE49-F238E27FC236}">
+                <a16:creationId xmlns:a16="http://schemas.microsoft.com/office/drawing/2014/main" id="{FEF9F6F0-10D3-CC44-912C-80D329FB5F3C}"/>
+              </a:ext>
+            </a:extLst>
+          </p:cNvPr>
+          <p:cNvSpPr/>
+          <p:nvPr/>
+        </p:nvSpPr>
+        <p:spPr>
+          <a:xfrm>
+            <a:off x="0" y="1447800"/>
+            <a:ext cx="1779638" cy="3962400"/>
           </a:xfrm>
           <a:prstGeom prst="rect">
             <a:avLst/>
@@ -4233,17 +4828,17 @@
             <a:pPr algn="ctr"/>
             <a:r>
               <a:rPr lang="en-CA" dirty="0"/>
-              <a:t>RAM</a:t>
-            </a:r>
-          </a:p>
-        </p:txBody>
-      </p:sp>
-      <p:sp>
-        <p:nvSpPr>
-          <p:cNvPr id="19" name="Arrow: Right 18">
-            <a:extLst>
-              <a:ext uri="{FF2B5EF4-FFF2-40B4-BE49-F238E27FC236}">
-                <a16:creationId xmlns:a16="http://schemas.microsoft.com/office/drawing/2014/main" id="{5A16AFD9-04ED-A34B-00B1-A9D3CE09B922}"/>
+              <a:t>File</a:t>
+            </a:r>
+          </a:p>
+        </p:txBody>
+      </p:sp>
+      <p:sp>
+        <p:nvSpPr>
+          <p:cNvPr id="15" name="Arrow: Right 14">
+            <a:extLst>
+              <a:ext uri="{FF2B5EF4-FFF2-40B4-BE49-F238E27FC236}">
+                <a16:creationId xmlns:a16="http://schemas.microsoft.com/office/drawing/2014/main" id="{54854930-83AB-D2BB-035E-DDEA1FA8DE37}"/>
               </a:ext>
             </a:extLst>
           </p:cNvPr>
@@ -4252,8 +4847,148 @@
         </p:nvSpPr>
         <p:spPr>
           <a:xfrm>
-            <a:off x="3088560" y="2689124"/>
-            <a:ext cx="1149143" cy="1219200"/>
+            <a:off x="1430597" y="2915266"/>
+            <a:ext cx="1499418" cy="1219200"/>
+          </a:xfrm>
+          <a:prstGeom prst="rightArrow">
+            <a:avLst/>
+          </a:prstGeom>
+        </p:spPr>
+        <p:style>
+          <a:lnRef idx="1">
+            <a:schemeClr val="accent2"/>
+          </a:lnRef>
+          <a:fillRef idx="3">
+            <a:schemeClr val="accent2"/>
+          </a:fillRef>
+          <a:effectRef idx="2">
+            <a:schemeClr val="accent2"/>
+          </a:effectRef>
+          <a:fontRef idx="minor">
+            <a:schemeClr val="lt1"/>
+          </a:fontRef>
+        </p:style>
+        <p:txBody>
+          <a:bodyPr rtlCol="0" anchor="ctr"/>
+          <a:lstStyle/>
+          <a:p>
+            <a:pPr algn="ctr"/>
+            <a:endParaRPr lang="en-CA"/>
+          </a:p>
+        </p:txBody>
+      </p:sp>
+      <p:sp>
+        <p:nvSpPr>
+          <p:cNvPr id="17" name="Rectangle 16">
+            <a:extLst>
+              <a:ext uri="{FF2B5EF4-FFF2-40B4-BE49-F238E27FC236}">
+                <a16:creationId xmlns:a16="http://schemas.microsoft.com/office/drawing/2014/main" id="{07BFFAB9-075E-CEEE-81DF-E3C0EF4A7A6A}"/>
+              </a:ext>
+            </a:extLst>
+          </p:cNvPr>
+          <p:cNvSpPr/>
+          <p:nvPr/>
+        </p:nvSpPr>
+        <p:spPr>
+          <a:xfrm>
+            <a:off x="2703879" y="1487131"/>
+            <a:ext cx="796409" cy="1619864"/>
+          </a:xfrm>
+          <a:prstGeom prst="rect">
+            <a:avLst/>
+          </a:prstGeom>
+        </p:spPr>
+        <p:style>
+          <a:lnRef idx="3">
+            <a:schemeClr val="lt1"/>
+          </a:lnRef>
+          <a:fillRef idx="1">
+            <a:schemeClr val="accent2"/>
+          </a:fillRef>
+          <a:effectRef idx="1">
+            <a:schemeClr val="accent2"/>
+          </a:effectRef>
+          <a:fontRef idx="minor">
+            <a:schemeClr val="lt1"/>
+          </a:fontRef>
+        </p:style>
+        <p:txBody>
+          <a:bodyPr rtlCol="0" anchor="ctr"/>
+          <a:lstStyle/>
+          <a:p>
+            <a:pPr algn="ctr"/>
+            <a:r>
+              <a:rPr lang="en-CA" dirty="0"/>
+              <a:t>Verts</a:t>
+            </a:r>
+          </a:p>
+        </p:txBody>
+      </p:sp>
+      <p:sp>
+        <p:nvSpPr>
+          <p:cNvPr id="18" name="Rectangle 17">
+            <a:extLst>
+              <a:ext uri="{FF2B5EF4-FFF2-40B4-BE49-F238E27FC236}">
+                <a16:creationId xmlns:a16="http://schemas.microsoft.com/office/drawing/2014/main" id="{BC83CAE1-9ED2-50EE-1550-D6F02FA2158D}"/>
+              </a:ext>
+            </a:extLst>
+          </p:cNvPr>
+          <p:cNvSpPr/>
+          <p:nvPr/>
+        </p:nvSpPr>
+        <p:spPr>
+          <a:xfrm>
+            <a:off x="2674379" y="3495369"/>
+            <a:ext cx="796409" cy="1619864"/>
+          </a:xfrm>
+          <a:prstGeom prst="rect">
+            <a:avLst/>
+          </a:prstGeom>
+        </p:spPr>
+        <p:style>
+          <a:lnRef idx="2">
+            <a:schemeClr val="accent4">
+              <a:shade val="15000"/>
+            </a:schemeClr>
+          </a:lnRef>
+          <a:fillRef idx="1">
+            <a:schemeClr val="accent4"/>
+          </a:fillRef>
+          <a:effectRef idx="0">
+            <a:schemeClr val="accent4"/>
+          </a:effectRef>
+          <a:fontRef idx="minor">
+            <a:schemeClr val="lt1"/>
+          </a:fontRef>
+        </p:style>
+        <p:txBody>
+          <a:bodyPr rtlCol="0" anchor="ctr"/>
+          <a:lstStyle/>
+          <a:p>
+            <a:pPr algn="ctr"/>
+            <a:r>
+              <a:rPr lang="en-CA" dirty="0"/>
+              <a:t>Faces</a:t>
+            </a:r>
+          </a:p>
+        </p:txBody>
+      </p:sp>
+      <p:sp>
+        <p:nvSpPr>
+          <p:cNvPr id="19" name="Arrow: Right 18">
+            <a:extLst>
+              <a:ext uri="{FF2B5EF4-FFF2-40B4-BE49-F238E27FC236}">
+                <a16:creationId xmlns:a16="http://schemas.microsoft.com/office/drawing/2014/main" id="{5A16AFD9-04ED-A34B-00B1-A9D3CE09B922}"/>
+              </a:ext>
+            </a:extLst>
+          </p:cNvPr>
+          <p:cNvSpPr/>
+          <p:nvPr/>
+        </p:nvSpPr>
+        <p:spPr>
+          <a:xfrm>
+            <a:off x="3244652" y="2689124"/>
+            <a:ext cx="849259" cy="1219200"/>
           </a:xfrm>
           <a:prstGeom prst="rightArrow">
             <a:avLst/>
@@ -4285,7 +5020,3387 @@
     </p:spTree>
     <p:extLst>
       <p:ext uri="{BB962C8B-B14F-4D97-AF65-F5344CB8AC3E}">
-        <p14:creationId xmlns:p14="http://schemas.microsoft.com/office/powerpoint/2010/main" val="800627848"/>
+        <p14:creationId xmlns:p14="http://schemas.microsoft.com/office/powerpoint/2010/main" val="2724904099"/>
+      </p:ext>
+    </p:extLst>
+  </p:cSld>
+  <p:clrMapOvr>
+    <a:masterClrMapping/>
+  </p:clrMapOvr>
+</p:sld>
+</file>
+
+<file path=ppt/slides/slide3.xml><?xml version="1.0" encoding="utf-8"?>
+<p:sld xmlns:a="http://schemas.openxmlformats.org/drawingml/2006/main" xmlns:r="http://schemas.openxmlformats.org/officeDocument/2006/relationships" xmlns:p="http://schemas.openxmlformats.org/presentationml/2006/main">
+  <p:cSld>
+    <p:spTree>
+      <p:nvGrpSpPr>
+        <p:cNvPr id="1" name=""/>
+        <p:cNvGrpSpPr/>
+        <p:nvPr/>
+      </p:nvGrpSpPr>
+      <p:grpSpPr>
+        <a:xfrm>
+          <a:off x="0" y="0"/>
+          <a:ext cx="0" cy="0"/>
+          <a:chOff x="0" y="0"/>
+          <a:chExt cx="0" cy="0"/>
+        </a:xfrm>
+      </p:grpSpPr>
+      <p:sp>
+        <p:nvSpPr>
+          <p:cNvPr id="5" name="Rectangle: Rounded Corners 4">
+            <a:extLst>
+              <a:ext uri="{FF2B5EF4-FFF2-40B4-BE49-F238E27FC236}">
+                <a16:creationId xmlns:a16="http://schemas.microsoft.com/office/drawing/2014/main" id="{855FD758-8CA8-97F0-86A6-673795C8D55E}"/>
+              </a:ext>
+            </a:extLst>
+          </p:cNvPr>
+          <p:cNvSpPr/>
+          <p:nvPr/>
+        </p:nvSpPr>
+        <p:spPr>
+          <a:xfrm>
+            <a:off x="2359742" y="88490"/>
+            <a:ext cx="2408903" cy="6459794"/>
+          </a:xfrm>
+          <a:prstGeom prst="roundRect">
+            <a:avLst/>
+          </a:prstGeom>
+        </p:spPr>
+        <p:style>
+          <a:lnRef idx="2">
+            <a:schemeClr val="accent1">
+              <a:shade val="15000"/>
+            </a:schemeClr>
+          </a:lnRef>
+          <a:fillRef idx="1">
+            <a:schemeClr val="accent1"/>
+          </a:fillRef>
+          <a:effectRef idx="0">
+            <a:schemeClr val="accent1"/>
+          </a:effectRef>
+          <a:fontRef idx="minor">
+            <a:schemeClr val="lt1"/>
+          </a:fontRef>
+        </p:style>
+        <p:txBody>
+          <a:bodyPr rtlCol="0" anchor="ctr"/>
+          <a:lstStyle/>
+          <a:p>
+            <a:pPr algn="ctr"/>
+            <a:r>
+              <a:rPr lang="en-CA" dirty="0"/>
+              <a:t>CPU (C++)</a:t>
+            </a:r>
+          </a:p>
+          <a:p>
+            <a:pPr algn="ctr"/>
+            <a:endParaRPr lang="en-CA" dirty="0"/>
+          </a:p>
+          <a:p>
+            <a:pPr algn="ctr"/>
+            <a:endParaRPr lang="en-CA" dirty="0"/>
+          </a:p>
+          <a:p>
+            <a:pPr algn="ctr"/>
+            <a:endParaRPr lang="en-CA" dirty="0"/>
+          </a:p>
+          <a:p>
+            <a:pPr algn="ctr"/>
+            <a:endParaRPr lang="en-CA" dirty="0"/>
+          </a:p>
+          <a:p>
+            <a:pPr algn="ctr"/>
+            <a:endParaRPr lang="en-CA" dirty="0"/>
+          </a:p>
+          <a:p>
+            <a:pPr algn="ctr"/>
+            <a:endParaRPr lang="en-CA" dirty="0"/>
+          </a:p>
+          <a:p>
+            <a:pPr algn="ctr"/>
+            <a:endParaRPr lang="en-CA" dirty="0"/>
+          </a:p>
+          <a:p>
+            <a:pPr algn="ctr"/>
+            <a:endParaRPr lang="en-CA" dirty="0"/>
+          </a:p>
+          <a:p>
+            <a:pPr algn="ctr"/>
+            <a:endParaRPr lang="en-CA" dirty="0"/>
+          </a:p>
+          <a:p>
+            <a:pPr algn="ctr"/>
+            <a:endParaRPr lang="en-CA" dirty="0"/>
+          </a:p>
+          <a:p>
+            <a:pPr algn="ctr"/>
+            <a:endParaRPr lang="en-CA" dirty="0"/>
+          </a:p>
+          <a:p>
+            <a:pPr algn="ctr"/>
+            <a:endParaRPr lang="en-CA" dirty="0"/>
+          </a:p>
+          <a:p>
+            <a:pPr algn="ctr"/>
+            <a:endParaRPr lang="en-CA" dirty="0"/>
+          </a:p>
+          <a:p>
+            <a:pPr algn="ctr"/>
+            <a:endParaRPr lang="en-CA" dirty="0"/>
+          </a:p>
+          <a:p>
+            <a:pPr algn="ctr"/>
+            <a:endParaRPr lang="en-CA" dirty="0"/>
+          </a:p>
+          <a:p>
+            <a:pPr algn="ctr"/>
+            <a:endParaRPr lang="en-CA" dirty="0"/>
+          </a:p>
+          <a:p>
+            <a:pPr algn="ctr"/>
+            <a:endParaRPr lang="en-CA" dirty="0"/>
+          </a:p>
+        </p:txBody>
+      </p:sp>
+      <p:sp>
+        <p:nvSpPr>
+          <p:cNvPr id="6" name="Rectangle: Rounded Corners 5">
+            <a:extLst>
+              <a:ext uri="{FF2B5EF4-FFF2-40B4-BE49-F238E27FC236}">
+                <a16:creationId xmlns:a16="http://schemas.microsoft.com/office/drawing/2014/main" id="{A7AB6A8E-617B-EFE7-82EB-41E6C14BB692}"/>
+              </a:ext>
+            </a:extLst>
+          </p:cNvPr>
+          <p:cNvSpPr/>
+          <p:nvPr/>
+        </p:nvSpPr>
+        <p:spPr>
+          <a:xfrm>
+            <a:off x="5830530" y="88490"/>
+            <a:ext cx="5309418" cy="6459794"/>
+          </a:xfrm>
+          <a:prstGeom prst="roundRect">
+            <a:avLst/>
+          </a:prstGeom>
+        </p:spPr>
+        <p:style>
+          <a:lnRef idx="2">
+            <a:schemeClr val="accent1">
+              <a:shade val="15000"/>
+            </a:schemeClr>
+          </a:lnRef>
+          <a:fillRef idx="1">
+            <a:schemeClr val="accent1"/>
+          </a:fillRef>
+          <a:effectRef idx="0">
+            <a:schemeClr val="accent1"/>
+          </a:effectRef>
+          <a:fontRef idx="minor">
+            <a:schemeClr val="lt1"/>
+          </a:fontRef>
+        </p:style>
+        <p:txBody>
+          <a:bodyPr rtlCol="0" anchor="ctr"/>
+          <a:lstStyle/>
+          <a:p>
+            <a:pPr algn="ctr"/>
+            <a:r>
+              <a:rPr lang="en-CA" dirty="0"/>
+              <a:t>GPU</a:t>
+            </a:r>
+          </a:p>
+          <a:p>
+            <a:pPr algn="ctr"/>
+            <a:endParaRPr lang="en-CA" dirty="0"/>
+          </a:p>
+          <a:p>
+            <a:pPr algn="ctr"/>
+            <a:endParaRPr lang="en-CA" dirty="0"/>
+          </a:p>
+          <a:p>
+            <a:pPr algn="ctr"/>
+            <a:endParaRPr lang="en-CA" dirty="0"/>
+          </a:p>
+          <a:p>
+            <a:pPr algn="ctr"/>
+            <a:endParaRPr lang="en-CA" dirty="0"/>
+          </a:p>
+          <a:p>
+            <a:pPr algn="ctr"/>
+            <a:endParaRPr lang="en-CA" dirty="0"/>
+          </a:p>
+          <a:p>
+            <a:pPr algn="ctr"/>
+            <a:endParaRPr lang="en-CA" dirty="0"/>
+          </a:p>
+          <a:p>
+            <a:pPr algn="ctr"/>
+            <a:endParaRPr lang="en-CA" dirty="0"/>
+          </a:p>
+          <a:p>
+            <a:pPr algn="ctr"/>
+            <a:endParaRPr lang="en-CA" dirty="0"/>
+          </a:p>
+          <a:p>
+            <a:pPr algn="ctr"/>
+            <a:endParaRPr lang="en-CA" dirty="0"/>
+          </a:p>
+          <a:p>
+            <a:pPr algn="ctr"/>
+            <a:endParaRPr lang="en-CA" dirty="0"/>
+          </a:p>
+          <a:p>
+            <a:pPr algn="ctr"/>
+            <a:endParaRPr lang="en-CA" dirty="0"/>
+          </a:p>
+          <a:p>
+            <a:pPr algn="ctr"/>
+            <a:endParaRPr lang="en-CA" dirty="0"/>
+          </a:p>
+          <a:p>
+            <a:pPr algn="ctr"/>
+            <a:endParaRPr lang="en-CA" dirty="0"/>
+          </a:p>
+          <a:p>
+            <a:pPr algn="ctr"/>
+            <a:endParaRPr lang="en-CA" dirty="0"/>
+          </a:p>
+          <a:p>
+            <a:pPr algn="ctr"/>
+            <a:endParaRPr lang="en-CA" dirty="0"/>
+          </a:p>
+          <a:p>
+            <a:pPr algn="ctr"/>
+            <a:endParaRPr lang="en-CA" dirty="0"/>
+          </a:p>
+          <a:p>
+            <a:pPr algn="ctr"/>
+            <a:endParaRPr lang="en-CA" dirty="0"/>
+          </a:p>
+        </p:txBody>
+      </p:sp>
+      <p:sp>
+        <p:nvSpPr>
+          <p:cNvPr id="7" name="Rectangle 6">
+            <a:extLst>
+              <a:ext uri="{FF2B5EF4-FFF2-40B4-BE49-F238E27FC236}">
+                <a16:creationId xmlns:a16="http://schemas.microsoft.com/office/drawing/2014/main" id="{A0A7DBA7-1C8E-1277-B21A-295B2BF3A4E4}"/>
+              </a:ext>
+            </a:extLst>
+          </p:cNvPr>
+          <p:cNvSpPr/>
+          <p:nvPr/>
+        </p:nvSpPr>
+        <p:spPr>
+          <a:xfrm>
+            <a:off x="6236115" y="1622323"/>
+            <a:ext cx="929146" cy="3962400"/>
+          </a:xfrm>
+          <a:prstGeom prst="rect">
+            <a:avLst/>
+          </a:prstGeom>
+        </p:spPr>
+        <p:style>
+          <a:lnRef idx="3">
+            <a:schemeClr val="lt1"/>
+          </a:lnRef>
+          <a:fillRef idx="1">
+            <a:schemeClr val="accent2"/>
+          </a:fillRef>
+          <a:effectRef idx="1">
+            <a:schemeClr val="accent2"/>
+          </a:effectRef>
+          <a:fontRef idx="minor">
+            <a:schemeClr val="lt1"/>
+          </a:fontRef>
+        </p:style>
+        <p:txBody>
+          <a:bodyPr rtlCol="0" anchor="ctr"/>
+          <a:lstStyle/>
+          <a:p>
+            <a:pPr algn="ctr"/>
+            <a:r>
+              <a:rPr lang="en-CA" dirty="0"/>
+              <a:t>Vertex</a:t>
+            </a:r>
+          </a:p>
+          <a:p>
+            <a:pPr algn="ctr"/>
+            <a:r>
+              <a:rPr lang="en-CA" dirty="0"/>
+              <a:t>buffer</a:t>
+            </a:r>
+          </a:p>
+        </p:txBody>
+      </p:sp>
+      <p:sp>
+        <p:nvSpPr>
+          <p:cNvPr id="8" name="Arrow: Right 7">
+            <a:extLst>
+              <a:ext uri="{FF2B5EF4-FFF2-40B4-BE49-F238E27FC236}">
+                <a16:creationId xmlns:a16="http://schemas.microsoft.com/office/drawing/2014/main" id="{9E9D5935-7A52-C77B-8374-E864BCEE7462}"/>
+              </a:ext>
+            </a:extLst>
+          </p:cNvPr>
+          <p:cNvSpPr/>
+          <p:nvPr/>
+        </p:nvSpPr>
+        <p:spPr>
+          <a:xfrm>
+            <a:off x="3785424" y="2689124"/>
+            <a:ext cx="2487559" cy="1219200"/>
+          </a:xfrm>
+          <a:prstGeom prst="rightArrow">
+            <a:avLst/>
+          </a:prstGeom>
+        </p:spPr>
+        <p:style>
+          <a:lnRef idx="1">
+            <a:schemeClr val="accent2"/>
+          </a:lnRef>
+          <a:fillRef idx="3">
+            <a:schemeClr val="accent2"/>
+          </a:fillRef>
+          <a:effectRef idx="2">
+            <a:schemeClr val="accent2"/>
+          </a:effectRef>
+          <a:fontRef idx="minor">
+            <a:schemeClr val="lt1"/>
+          </a:fontRef>
+        </p:style>
+        <p:txBody>
+          <a:bodyPr rtlCol="0" anchor="ctr"/>
+          <a:lstStyle/>
+          <a:p>
+            <a:pPr algn="ctr"/>
+            <a:endParaRPr lang="en-CA" dirty="0"/>
+          </a:p>
+        </p:txBody>
+      </p:sp>
+      <p:sp>
+        <p:nvSpPr>
+          <p:cNvPr id="11" name="Rectangle: Rounded Corners 10">
+            <a:extLst>
+              <a:ext uri="{FF2B5EF4-FFF2-40B4-BE49-F238E27FC236}">
+                <a16:creationId xmlns:a16="http://schemas.microsoft.com/office/drawing/2014/main" id="{DD8208FC-83C2-3DB4-987C-E51904197546}"/>
+              </a:ext>
+            </a:extLst>
+          </p:cNvPr>
+          <p:cNvSpPr/>
+          <p:nvPr/>
+        </p:nvSpPr>
+        <p:spPr>
+          <a:xfrm>
+            <a:off x="8554065" y="1622323"/>
+            <a:ext cx="2792361" cy="2969343"/>
+          </a:xfrm>
+          <a:prstGeom prst="roundRect">
+            <a:avLst/>
+          </a:prstGeom>
+        </p:spPr>
+        <p:style>
+          <a:lnRef idx="2">
+            <a:schemeClr val="accent1">
+              <a:shade val="15000"/>
+            </a:schemeClr>
+          </a:lnRef>
+          <a:fillRef idx="1">
+            <a:schemeClr val="accent1"/>
+          </a:fillRef>
+          <a:effectRef idx="0">
+            <a:schemeClr val="accent1"/>
+          </a:effectRef>
+          <a:fontRef idx="minor">
+            <a:schemeClr val="lt1"/>
+          </a:fontRef>
+        </p:style>
+        <p:txBody>
+          <a:bodyPr rtlCol="0" anchor="ctr"/>
+          <a:lstStyle/>
+          <a:p>
+            <a:pPr algn="ctr"/>
+            <a:r>
+              <a:rPr lang="en-CA" dirty="0"/>
+              <a:t>Shader “Program”</a:t>
+            </a:r>
+          </a:p>
+          <a:p>
+            <a:pPr algn="ctr"/>
+            <a:endParaRPr lang="en-CA" dirty="0"/>
+          </a:p>
+          <a:p>
+            <a:pPr algn="ctr"/>
+            <a:endParaRPr lang="en-CA" dirty="0"/>
+          </a:p>
+          <a:p>
+            <a:pPr algn="ctr"/>
+            <a:endParaRPr lang="en-CA" dirty="0"/>
+          </a:p>
+          <a:p>
+            <a:pPr algn="ctr"/>
+            <a:endParaRPr lang="en-CA" dirty="0"/>
+          </a:p>
+          <a:p>
+            <a:pPr algn="ctr"/>
+            <a:endParaRPr lang="en-CA" dirty="0"/>
+          </a:p>
+          <a:p>
+            <a:pPr algn="ctr"/>
+            <a:endParaRPr lang="en-CA" dirty="0"/>
+          </a:p>
+          <a:p>
+            <a:pPr algn="ctr"/>
+            <a:endParaRPr lang="en-CA" dirty="0"/>
+          </a:p>
+          <a:p>
+            <a:pPr algn="ctr"/>
+            <a:endParaRPr lang="en-CA" dirty="0"/>
+          </a:p>
+          <a:p>
+            <a:pPr algn="ctr"/>
+            <a:endParaRPr lang="en-CA" dirty="0"/>
+          </a:p>
+        </p:txBody>
+      </p:sp>
+      <p:sp>
+        <p:nvSpPr>
+          <p:cNvPr id="9" name="Rectangle: Rounded Corners 8">
+            <a:extLst>
+              <a:ext uri="{FF2B5EF4-FFF2-40B4-BE49-F238E27FC236}">
+                <a16:creationId xmlns:a16="http://schemas.microsoft.com/office/drawing/2014/main" id="{C770166A-DA62-5E5D-EC57-615034048C5E}"/>
+              </a:ext>
+            </a:extLst>
+          </p:cNvPr>
+          <p:cNvSpPr/>
+          <p:nvPr/>
+        </p:nvSpPr>
+        <p:spPr>
+          <a:xfrm>
+            <a:off x="9026013" y="2271253"/>
+            <a:ext cx="1986116" cy="835742"/>
+          </a:xfrm>
+          <a:prstGeom prst="roundRect">
+            <a:avLst/>
+          </a:prstGeom>
+        </p:spPr>
+        <p:style>
+          <a:lnRef idx="3">
+            <a:schemeClr val="lt1"/>
+          </a:lnRef>
+          <a:fillRef idx="1">
+            <a:schemeClr val="accent4"/>
+          </a:fillRef>
+          <a:effectRef idx="1">
+            <a:schemeClr val="accent4"/>
+          </a:effectRef>
+          <a:fontRef idx="minor">
+            <a:schemeClr val="lt1"/>
+          </a:fontRef>
+        </p:style>
+        <p:txBody>
+          <a:bodyPr rtlCol="0" anchor="ctr"/>
+          <a:lstStyle/>
+          <a:p>
+            <a:pPr algn="ctr"/>
+            <a:r>
+              <a:rPr lang="en-CA" dirty="0">
+                <a:solidFill>
+                  <a:schemeClr val="tx1"/>
+                </a:solidFill>
+              </a:rPr>
+              <a:t>Vertex</a:t>
+            </a:r>
+          </a:p>
+        </p:txBody>
+      </p:sp>
+      <p:sp>
+        <p:nvSpPr>
+          <p:cNvPr id="10" name="Rectangle: Rounded Corners 9">
+            <a:extLst>
+              <a:ext uri="{FF2B5EF4-FFF2-40B4-BE49-F238E27FC236}">
+                <a16:creationId xmlns:a16="http://schemas.microsoft.com/office/drawing/2014/main" id="{F55A8CC1-47C2-1E03-2710-00949FBA61EF}"/>
+              </a:ext>
+            </a:extLst>
+          </p:cNvPr>
+          <p:cNvSpPr/>
+          <p:nvPr/>
+        </p:nvSpPr>
+        <p:spPr>
+          <a:xfrm>
+            <a:off x="9026013" y="3298724"/>
+            <a:ext cx="1986116" cy="835742"/>
+          </a:xfrm>
+          <a:prstGeom prst="roundRect">
+            <a:avLst/>
+          </a:prstGeom>
+        </p:spPr>
+        <p:style>
+          <a:lnRef idx="3">
+            <a:schemeClr val="lt1"/>
+          </a:lnRef>
+          <a:fillRef idx="1">
+            <a:schemeClr val="accent4"/>
+          </a:fillRef>
+          <a:effectRef idx="1">
+            <a:schemeClr val="accent4"/>
+          </a:effectRef>
+          <a:fontRef idx="minor">
+            <a:schemeClr val="lt1"/>
+          </a:fontRef>
+        </p:style>
+        <p:txBody>
+          <a:bodyPr rtlCol="0" anchor="ctr"/>
+          <a:lstStyle/>
+          <a:p>
+            <a:pPr algn="ctr"/>
+            <a:r>
+              <a:rPr lang="en-CA" dirty="0">
+                <a:solidFill>
+                  <a:schemeClr val="tx1"/>
+                </a:solidFill>
+              </a:rPr>
+              <a:t>Fragment</a:t>
+            </a:r>
+          </a:p>
+        </p:txBody>
+      </p:sp>
+      <p:sp>
+        <p:nvSpPr>
+          <p:cNvPr id="12" name="Arrow: Right 11">
+            <a:extLst>
+              <a:ext uri="{FF2B5EF4-FFF2-40B4-BE49-F238E27FC236}">
+                <a16:creationId xmlns:a16="http://schemas.microsoft.com/office/drawing/2014/main" id="{A94E4D52-A290-E5D3-0494-1F5571B038C3}"/>
+              </a:ext>
+            </a:extLst>
+          </p:cNvPr>
+          <p:cNvSpPr/>
+          <p:nvPr/>
+        </p:nvSpPr>
+        <p:spPr>
+          <a:xfrm>
+            <a:off x="11611896" y="2571136"/>
+            <a:ext cx="2261420" cy="1219200"/>
+          </a:xfrm>
+          <a:prstGeom prst="rightArrow">
+            <a:avLst/>
+          </a:prstGeom>
+        </p:spPr>
+        <p:style>
+          <a:lnRef idx="1">
+            <a:schemeClr val="accent2"/>
+          </a:lnRef>
+          <a:fillRef idx="3">
+            <a:schemeClr val="accent2"/>
+          </a:fillRef>
+          <a:effectRef idx="2">
+            <a:schemeClr val="accent2"/>
+          </a:effectRef>
+          <a:fontRef idx="minor">
+            <a:schemeClr val="lt1"/>
+          </a:fontRef>
+        </p:style>
+        <p:txBody>
+          <a:bodyPr rtlCol="0" anchor="ctr"/>
+          <a:lstStyle/>
+          <a:p>
+            <a:pPr algn="ctr"/>
+            <a:r>
+              <a:rPr lang="en-CA" dirty="0"/>
+              <a:t>To the screen (back buffer)</a:t>
+            </a:r>
+          </a:p>
+        </p:txBody>
+      </p:sp>
+      <p:sp>
+        <p:nvSpPr>
+          <p:cNvPr id="13" name="Arrow: Right 12">
+            <a:extLst>
+              <a:ext uri="{FF2B5EF4-FFF2-40B4-BE49-F238E27FC236}">
+                <a16:creationId xmlns:a16="http://schemas.microsoft.com/office/drawing/2014/main" id="{5F240329-D1AC-2AA6-9E5F-9F28FBD8DB21}"/>
+              </a:ext>
+            </a:extLst>
+          </p:cNvPr>
+          <p:cNvSpPr/>
+          <p:nvPr/>
+        </p:nvSpPr>
+        <p:spPr>
+          <a:xfrm>
+            <a:off x="7993626" y="2664543"/>
+            <a:ext cx="1194623" cy="1219200"/>
+          </a:xfrm>
+          <a:prstGeom prst="rightArrow">
+            <a:avLst/>
+          </a:prstGeom>
+        </p:spPr>
+        <p:style>
+          <a:lnRef idx="1">
+            <a:schemeClr val="accent2"/>
+          </a:lnRef>
+          <a:fillRef idx="3">
+            <a:schemeClr val="accent2"/>
+          </a:fillRef>
+          <a:effectRef idx="2">
+            <a:schemeClr val="accent2"/>
+          </a:effectRef>
+          <a:fontRef idx="minor">
+            <a:schemeClr val="lt1"/>
+          </a:fontRef>
+        </p:style>
+        <p:txBody>
+          <a:bodyPr rtlCol="0" anchor="ctr"/>
+          <a:lstStyle/>
+          <a:p>
+            <a:pPr algn="ctr"/>
+            <a:endParaRPr lang="en-CA"/>
+          </a:p>
+        </p:txBody>
+      </p:sp>
+      <p:sp>
+        <p:nvSpPr>
+          <p:cNvPr id="14" name="Rectangle 13">
+            <a:extLst>
+              <a:ext uri="{FF2B5EF4-FFF2-40B4-BE49-F238E27FC236}">
+                <a16:creationId xmlns:a16="http://schemas.microsoft.com/office/drawing/2014/main" id="{FEF9F6F0-10D3-CC44-912C-80D329FB5F3C}"/>
+              </a:ext>
+            </a:extLst>
+          </p:cNvPr>
+          <p:cNvSpPr/>
+          <p:nvPr/>
+        </p:nvSpPr>
+        <p:spPr>
+          <a:xfrm>
+            <a:off x="29490" y="585022"/>
+            <a:ext cx="1779638" cy="2521973"/>
+          </a:xfrm>
+          <a:prstGeom prst="rect">
+            <a:avLst/>
+          </a:prstGeom>
+        </p:spPr>
+        <p:style>
+          <a:lnRef idx="3">
+            <a:schemeClr val="lt1"/>
+          </a:lnRef>
+          <a:fillRef idx="1">
+            <a:schemeClr val="accent6"/>
+          </a:fillRef>
+          <a:effectRef idx="1">
+            <a:schemeClr val="accent6"/>
+          </a:effectRef>
+          <a:fontRef idx="minor">
+            <a:schemeClr val="lt1"/>
+          </a:fontRef>
+        </p:style>
+        <p:txBody>
+          <a:bodyPr rtlCol="0" anchor="ctr"/>
+          <a:lstStyle/>
+          <a:p>
+            <a:pPr algn="ctr"/>
+            <a:r>
+              <a:rPr lang="en-CA" dirty="0"/>
+              <a:t>File</a:t>
+            </a:r>
+          </a:p>
+        </p:txBody>
+      </p:sp>
+      <p:sp>
+        <p:nvSpPr>
+          <p:cNvPr id="15" name="Arrow: Right 14">
+            <a:extLst>
+              <a:ext uri="{FF2B5EF4-FFF2-40B4-BE49-F238E27FC236}">
+                <a16:creationId xmlns:a16="http://schemas.microsoft.com/office/drawing/2014/main" id="{54854930-83AB-D2BB-035E-DDEA1FA8DE37}"/>
+              </a:ext>
+            </a:extLst>
+          </p:cNvPr>
+          <p:cNvSpPr/>
+          <p:nvPr/>
+        </p:nvSpPr>
+        <p:spPr>
+          <a:xfrm>
+            <a:off x="1334726" y="1388807"/>
+            <a:ext cx="1499418" cy="1219200"/>
+          </a:xfrm>
+          <a:prstGeom prst="rightArrow">
+            <a:avLst/>
+          </a:prstGeom>
+        </p:spPr>
+        <p:style>
+          <a:lnRef idx="1">
+            <a:schemeClr val="accent2"/>
+          </a:lnRef>
+          <a:fillRef idx="3">
+            <a:schemeClr val="accent2"/>
+          </a:fillRef>
+          <a:effectRef idx="2">
+            <a:schemeClr val="accent2"/>
+          </a:effectRef>
+          <a:fontRef idx="minor">
+            <a:schemeClr val="lt1"/>
+          </a:fontRef>
+        </p:style>
+        <p:txBody>
+          <a:bodyPr rtlCol="0" anchor="ctr"/>
+          <a:lstStyle/>
+          <a:p>
+            <a:pPr algn="ctr"/>
+            <a:endParaRPr lang="en-CA"/>
+          </a:p>
+        </p:txBody>
+      </p:sp>
+      <p:sp>
+        <p:nvSpPr>
+          <p:cNvPr id="16" name="Rectangle 15">
+            <a:extLst>
+              <a:ext uri="{FF2B5EF4-FFF2-40B4-BE49-F238E27FC236}">
+                <a16:creationId xmlns:a16="http://schemas.microsoft.com/office/drawing/2014/main" id="{AE5473DE-6B16-9DD1-C107-558517EF26D8}"/>
+              </a:ext>
+            </a:extLst>
+          </p:cNvPr>
+          <p:cNvSpPr/>
+          <p:nvPr/>
+        </p:nvSpPr>
+        <p:spPr>
+          <a:xfrm>
+            <a:off x="7359449" y="1639531"/>
+            <a:ext cx="929146" cy="3962400"/>
+          </a:xfrm>
+          <a:prstGeom prst="rect">
+            <a:avLst/>
+          </a:prstGeom>
+        </p:spPr>
+        <p:style>
+          <a:lnRef idx="2">
+            <a:schemeClr val="accent4">
+              <a:shade val="15000"/>
+            </a:schemeClr>
+          </a:lnRef>
+          <a:fillRef idx="1">
+            <a:schemeClr val="accent4"/>
+          </a:fillRef>
+          <a:effectRef idx="0">
+            <a:schemeClr val="accent4"/>
+          </a:effectRef>
+          <a:fontRef idx="minor">
+            <a:schemeClr val="lt1"/>
+          </a:fontRef>
+        </p:style>
+        <p:txBody>
+          <a:bodyPr rtlCol="0" anchor="ctr"/>
+          <a:lstStyle/>
+          <a:p>
+            <a:pPr algn="ctr"/>
+            <a:r>
+              <a:rPr lang="en-CA" dirty="0"/>
+              <a:t>Index</a:t>
+            </a:r>
+          </a:p>
+          <a:p>
+            <a:pPr algn="ctr"/>
+            <a:r>
+              <a:rPr lang="en-CA" dirty="0"/>
+              <a:t>buffer</a:t>
+            </a:r>
+          </a:p>
+        </p:txBody>
+      </p:sp>
+      <p:sp>
+        <p:nvSpPr>
+          <p:cNvPr id="2" name="Rectangle 1">
+            <a:extLst>
+              <a:ext uri="{FF2B5EF4-FFF2-40B4-BE49-F238E27FC236}">
+                <a16:creationId xmlns:a16="http://schemas.microsoft.com/office/drawing/2014/main" id="{DB77F629-9FE4-9D27-A91B-F9E1EC7F6099}"/>
+              </a:ext>
+            </a:extLst>
+          </p:cNvPr>
+          <p:cNvSpPr/>
+          <p:nvPr/>
+        </p:nvSpPr>
+        <p:spPr>
+          <a:xfrm>
+            <a:off x="2841524" y="688262"/>
+            <a:ext cx="796409" cy="1619864"/>
+          </a:xfrm>
+          <a:prstGeom prst="rect">
+            <a:avLst/>
+          </a:prstGeom>
+        </p:spPr>
+        <p:style>
+          <a:lnRef idx="3">
+            <a:schemeClr val="lt1"/>
+          </a:lnRef>
+          <a:fillRef idx="1">
+            <a:schemeClr val="accent2"/>
+          </a:fillRef>
+          <a:effectRef idx="1">
+            <a:schemeClr val="accent2"/>
+          </a:effectRef>
+          <a:fontRef idx="minor">
+            <a:schemeClr val="lt1"/>
+          </a:fontRef>
+        </p:style>
+        <p:txBody>
+          <a:bodyPr rtlCol="0" anchor="ctr"/>
+          <a:lstStyle/>
+          <a:p>
+            <a:pPr algn="ctr"/>
+            <a:r>
+              <a:rPr lang="en-CA" dirty="0"/>
+              <a:t>Verts</a:t>
+            </a:r>
+          </a:p>
+        </p:txBody>
+      </p:sp>
+      <p:sp>
+        <p:nvSpPr>
+          <p:cNvPr id="3" name="Rectangle 2">
+            <a:extLst>
+              <a:ext uri="{FF2B5EF4-FFF2-40B4-BE49-F238E27FC236}">
+                <a16:creationId xmlns:a16="http://schemas.microsoft.com/office/drawing/2014/main" id="{89B9E140-32E1-9B41-9751-D0771A89CD48}"/>
+              </a:ext>
+            </a:extLst>
+          </p:cNvPr>
+          <p:cNvSpPr/>
+          <p:nvPr/>
+        </p:nvSpPr>
+        <p:spPr>
+          <a:xfrm>
+            <a:off x="2841524" y="2370804"/>
+            <a:ext cx="796409" cy="1619864"/>
+          </a:xfrm>
+          <a:prstGeom prst="rect">
+            <a:avLst/>
+          </a:prstGeom>
+        </p:spPr>
+        <p:style>
+          <a:lnRef idx="2">
+            <a:schemeClr val="accent4">
+              <a:shade val="15000"/>
+            </a:schemeClr>
+          </a:lnRef>
+          <a:fillRef idx="1">
+            <a:schemeClr val="accent4"/>
+          </a:fillRef>
+          <a:effectRef idx="0">
+            <a:schemeClr val="accent4"/>
+          </a:effectRef>
+          <a:fontRef idx="minor">
+            <a:schemeClr val="lt1"/>
+          </a:fontRef>
+        </p:style>
+        <p:txBody>
+          <a:bodyPr rtlCol="0" anchor="ctr"/>
+          <a:lstStyle/>
+          <a:p>
+            <a:pPr algn="ctr"/>
+            <a:r>
+              <a:rPr lang="en-CA" dirty="0"/>
+              <a:t>Faces</a:t>
+            </a:r>
+          </a:p>
+        </p:txBody>
+      </p:sp>
+    </p:spTree>
+    <p:extLst>
+      <p:ext uri="{BB962C8B-B14F-4D97-AF65-F5344CB8AC3E}">
+        <p14:creationId xmlns:p14="http://schemas.microsoft.com/office/powerpoint/2010/main" val="1250379301"/>
+      </p:ext>
+    </p:extLst>
+  </p:cSld>
+  <p:clrMapOvr>
+    <a:masterClrMapping/>
+  </p:clrMapOvr>
+</p:sld>
+</file>
+
+<file path=ppt/slides/slide4.xml><?xml version="1.0" encoding="utf-8"?>
+<p:sld xmlns:a="http://schemas.openxmlformats.org/drawingml/2006/main" xmlns:r="http://schemas.openxmlformats.org/officeDocument/2006/relationships" xmlns:p="http://schemas.openxmlformats.org/presentationml/2006/main">
+  <p:cSld>
+    <p:spTree>
+      <p:nvGrpSpPr>
+        <p:cNvPr id="1" name=""/>
+        <p:cNvGrpSpPr/>
+        <p:nvPr/>
+      </p:nvGrpSpPr>
+      <p:grpSpPr>
+        <a:xfrm>
+          <a:off x="0" y="0"/>
+          <a:ext cx="0" cy="0"/>
+          <a:chOff x="0" y="0"/>
+          <a:chExt cx="0" cy="0"/>
+        </a:xfrm>
+      </p:grpSpPr>
+      <p:sp>
+        <p:nvSpPr>
+          <p:cNvPr id="5" name="Rectangle: Rounded Corners 4">
+            <a:extLst>
+              <a:ext uri="{FF2B5EF4-FFF2-40B4-BE49-F238E27FC236}">
+                <a16:creationId xmlns:a16="http://schemas.microsoft.com/office/drawing/2014/main" id="{855FD758-8CA8-97F0-86A6-673795C8D55E}"/>
+              </a:ext>
+            </a:extLst>
+          </p:cNvPr>
+          <p:cNvSpPr/>
+          <p:nvPr/>
+        </p:nvSpPr>
+        <p:spPr>
+          <a:xfrm>
+            <a:off x="2359742" y="88490"/>
+            <a:ext cx="2408903" cy="6459794"/>
+          </a:xfrm>
+          <a:prstGeom prst="roundRect">
+            <a:avLst/>
+          </a:prstGeom>
+        </p:spPr>
+        <p:style>
+          <a:lnRef idx="2">
+            <a:schemeClr val="accent1">
+              <a:shade val="15000"/>
+            </a:schemeClr>
+          </a:lnRef>
+          <a:fillRef idx="1">
+            <a:schemeClr val="accent1"/>
+          </a:fillRef>
+          <a:effectRef idx="0">
+            <a:schemeClr val="accent1"/>
+          </a:effectRef>
+          <a:fontRef idx="minor">
+            <a:schemeClr val="lt1"/>
+          </a:fontRef>
+        </p:style>
+        <p:txBody>
+          <a:bodyPr rtlCol="0" anchor="ctr"/>
+          <a:lstStyle/>
+          <a:p>
+            <a:pPr algn="ctr"/>
+            <a:r>
+              <a:rPr lang="en-CA" dirty="0"/>
+              <a:t>CPU (C++)</a:t>
+            </a:r>
+          </a:p>
+          <a:p>
+            <a:pPr algn="ctr"/>
+            <a:endParaRPr lang="en-CA" dirty="0"/>
+          </a:p>
+          <a:p>
+            <a:pPr algn="ctr"/>
+            <a:endParaRPr lang="en-CA" dirty="0"/>
+          </a:p>
+          <a:p>
+            <a:pPr algn="ctr"/>
+            <a:endParaRPr lang="en-CA" dirty="0"/>
+          </a:p>
+          <a:p>
+            <a:pPr algn="ctr"/>
+            <a:endParaRPr lang="en-CA" dirty="0"/>
+          </a:p>
+          <a:p>
+            <a:pPr algn="ctr"/>
+            <a:endParaRPr lang="en-CA" dirty="0"/>
+          </a:p>
+          <a:p>
+            <a:pPr algn="ctr"/>
+            <a:endParaRPr lang="en-CA" dirty="0"/>
+          </a:p>
+          <a:p>
+            <a:pPr algn="ctr"/>
+            <a:endParaRPr lang="en-CA" dirty="0"/>
+          </a:p>
+          <a:p>
+            <a:pPr algn="ctr"/>
+            <a:endParaRPr lang="en-CA" dirty="0"/>
+          </a:p>
+          <a:p>
+            <a:pPr algn="ctr"/>
+            <a:endParaRPr lang="en-CA" dirty="0"/>
+          </a:p>
+          <a:p>
+            <a:pPr algn="ctr"/>
+            <a:endParaRPr lang="en-CA" dirty="0"/>
+          </a:p>
+          <a:p>
+            <a:pPr algn="ctr"/>
+            <a:endParaRPr lang="en-CA" dirty="0"/>
+          </a:p>
+          <a:p>
+            <a:pPr algn="ctr"/>
+            <a:endParaRPr lang="en-CA" dirty="0"/>
+          </a:p>
+          <a:p>
+            <a:pPr algn="ctr"/>
+            <a:endParaRPr lang="en-CA" dirty="0"/>
+          </a:p>
+          <a:p>
+            <a:pPr algn="ctr"/>
+            <a:endParaRPr lang="en-CA" dirty="0"/>
+          </a:p>
+          <a:p>
+            <a:pPr algn="ctr"/>
+            <a:endParaRPr lang="en-CA" dirty="0"/>
+          </a:p>
+          <a:p>
+            <a:pPr algn="ctr"/>
+            <a:endParaRPr lang="en-CA" dirty="0"/>
+          </a:p>
+          <a:p>
+            <a:pPr algn="ctr"/>
+            <a:endParaRPr lang="en-CA" dirty="0"/>
+          </a:p>
+        </p:txBody>
+      </p:sp>
+      <p:sp>
+        <p:nvSpPr>
+          <p:cNvPr id="6" name="Rectangle: Rounded Corners 5">
+            <a:extLst>
+              <a:ext uri="{FF2B5EF4-FFF2-40B4-BE49-F238E27FC236}">
+                <a16:creationId xmlns:a16="http://schemas.microsoft.com/office/drawing/2014/main" id="{A7AB6A8E-617B-EFE7-82EB-41E6C14BB692}"/>
+              </a:ext>
+            </a:extLst>
+          </p:cNvPr>
+          <p:cNvSpPr/>
+          <p:nvPr/>
+        </p:nvSpPr>
+        <p:spPr>
+          <a:xfrm>
+            <a:off x="5830530" y="88490"/>
+            <a:ext cx="5309418" cy="6459794"/>
+          </a:xfrm>
+          <a:prstGeom prst="roundRect">
+            <a:avLst/>
+          </a:prstGeom>
+        </p:spPr>
+        <p:style>
+          <a:lnRef idx="2">
+            <a:schemeClr val="accent1">
+              <a:shade val="15000"/>
+            </a:schemeClr>
+          </a:lnRef>
+          <a:fillRef idx="1">
+            <a:schemeClr val="accent1"/>
+          </a:fillRef>
+          <a:effectRef idx="0">
+            <a:schemeClr val="accent1"/>
+          </a:effectRef>
+          <a:fontRef idx="minor">
+            <a:schemeClr val="lt1"/>
+          </a:fontRef>
+        </p:style>
+        <p:txBody>
+          <a:bodyPr rtlCol="0" anchor="ctr"/>
+          <a:lstStyle/>
+          <a:p>
+            <a:pPr algn="ctr"/>
+            <a:r>
+              <a:rPr lang="en-CA" dirty="0"/>
+              <a:t>GPU</a:t>
+            </a:r>
+          </a:p>
+          <a:p>
+            <a:pPr algn="ctr"/>
+            <a:endParaRPr lang="en-CA" dirty="0"/>
+          </a:p>
+          <a:p>
+            <a:pPr algn="ctr"/>
+            <a:endParaRPr lang="en-CA" dirty="0"/>
+          </a:p>
+          <a:p>
+            <a:pPr algn="ctr"/>
+            <a:endParaRPr lang="en-CA" dirty="0"/>
+          </a:p>
+          <a:p>
+            <a:pPr algn="ctr"/>
+            <a:endParaRPr lang="en-CA" dirty="0"/>
+          </a:p>
+          <a:p>
+            <a:pPr algn="ctr"/>
+            <a:endParaRPr lang="en-CA" dirty="0"/>
+          </a:p>
+          <a:p>
+            <a:pPr algn="ctr"/>
+            <a:endParaRPr lang="en-CA" dirty="0"/>
+          </a:p>
+          <a:p>
+            <a:pPr algn="ctr"/>
+            <a:endParaRPr lang="en-CA" dirty="0"/>
+          </a:p>
+          <a:p>
+            <a:pPr algn="ctr"/>
+            <a:endParaRPr lang="en-CA" dirty="0"/>
+          </a:p>
+          <a:p>
+            <a:pPr algn="ctr"/>
+            <a:endParaRPr lang="en-CA" dirty="0"/>
+          </a:p>
+          <a:p>
+            <a:pPr algn="ctr"/>
+            <a:endParaRPr lang="en-CA" dirty="0"/>
+          </a:p>
+          <a:p>
+            <a:pPr algn="ctr"/>
+            <a:endParaRPr lang="en-CA" dirty="0"/>
+          </a:p>
+          <a:p>
+            <a:pPr algn="ctr"/>
+            <a:endParaRPr lang="en-CA" dirty="0"/>
+          </a:p>
+          <a:p>
+            <a:pPr algn="ctr"/>
+            <a:endParaRPr lang="en-CA" dirty="0"/>
+          </a:p>
+          <a:p>
+            <a:pPr algn="ctr"/>
+            <a:endParaRPr lang="en-CA" dirty="0"/>
+          </a:p>
+          <a:p>
+            <a:pPr algn="ctr"/>
+            <a:endParaRPr lang="en-CA" dirty="0"/>
+          </a:p>
+          <a:p>
+            <a:pPr algn="ctr"/>
+            <a:endParaRPr lang="en-CA" dirty="0"/>
+          </a:p>
+          <a:p>
+            <a:pPr algn="ctr"/>
+            <a:endParaRPr lang="en-CA" dirty="0"/>
+          </a:p>
+        </p:txBody>
+      </p:sp>
+      <p:sp>
+        <p:nvSpPr>
+          <p:cNvPr id="7" name="Rectangle 6">
+            <a:extLst>
+              <a:ext uri="{FF2B5EF4-FFF2-40B4-BE49-F238E27FC236}">
+                <a16:creationId xmlns:a16="http://schemas.microsoft.com/office/drawing/2014/main" id="{A0A7DBA7-1C8E-1277-B21A-295B2BF3A4E4}"/>
+              </a:ext>
+            </a:extLst>
+          </p:cNvPr>
+          <p:cNvSpPr/>
+          <p:nvPr/>
+        </p:nvSpPr>
+        <p:spPr>
+          <a:xfrm>
+            <a:off x="6255777" y="565358"/>
+            <a:ext cx="929146" cy="2863642"/>
+          </a:xfrm>
+          <a:prstGeom prst="rect">
+            <a:avLst/>
+          </a:prstGeom>
+        </p:spPr>
+        <p:style>
+          <a:lnRef idx="3">
+            <a:schemeClr val="lt1"/>
+          </a:lnRef>
+          <a:fillRef idx="1">
+            <a:schemeClr val="accent2"/>
+          </a:fillRef>
+          <a:effectRef idx="1">
+            <a:schemeClr val="accent2"/>
+          </a:effectRef>
+          <a:fontRef idx="minor">
+            <a:schemeClr val="lt1"/>
+          </a:fontRef>
+        </p:style>
+        <p:txBody>
+          <a:bodyPr rtlCol="0" anchor="ctr"/>
+          <a:lstStyle/>
+          <a:p>
+            <a:pPr algn="ctr"/>
+            <a:r>
+              <a:rPr lang="en-CA" dirty="0"/>
+              <a:t>Vertex</a:t>
+            </a:r>
+          </a:p>
+          <a:p>
+            <a:pPr algn="ctr"/>
+            <a:r>
+              <a:rPr lang="en-CA" dirty="0"/>
+              <a:t>buffer</a:t>
+            </a:r>
+          </a:p>
+        </p:txBody>
+      </p:sp>
+      <p:sp>
+        <p:nvSpPr>
+          <p:cNvPr id="8" name="Arrow: Right 7">
+            <a:extLst>
+              <a:ext uri="{FF2B5EF4-FFF2-40B4-BE49-F238E27FC236}">
+                <a16:creationId xmlns:a16="http://schemas.microsoft.com/office/drawing/2014/main" id="{9E9D5935-7A52-C77B-8374-E864BCEE7462}"/>
+              </a:ext>
+            </a:extLst>
+          </p:cNvPr>
+          <p:cNvSpPr/>
+          <p:nvPr/>
+        </p:nvSpPr>
+        <p:spPr>
+          <a:xfrm>
+            <a:off x="3785424" y="2689124"/>
+            <a:ext cx="2487559" cy="1219200"/>
+          </a:xfrm>
+          <a:prstGeom prst="rightArrow">
+            <a:avLst/>
+          </a:prstGeom>
+        </p:spPr>
+        <p:style>
+          <a:lnRef idx="1">
+            <a:schemeClr val="accent2"/>
+          </a:lnRef>
+          <a:fillRef idx="3">
+            <a:schemeClr val="accent2"/>
+          </a:fillRef>
+          <a:effectRef idx="2">
+            <a:schemeClr val="accent2"/>
+          </a:effectRef>
+          <a:fontRef idx="minor">
+            <a:schemeClr val="lt1"/>
+          </a:fontRef>
+        </p:style>
+        <p:txBody>
+          <a:bodyPr rtlCol="0" anchor="ctr"/>
+          <a:lstStyle/>
+          <a:p>
+            <a:pPr algn="ctr"/>
+            <a:endParaRPr lang="en-CA" dirty="0"/>
+          </a:p>
+        </p:txBody>
+      </p:sp>
+      <p:sp>
+        <p:nvSpPr>
+          <p:cNvPr id="11" name="Rectangle: Rounded Corners 10">
+            <a:extLst>
+              <a:ext uri="{FF2B5EF4-FFF2-40B4-BE49-F238E27FC236}">
+                <a16:creationId xmlns:a16="http://schemas.microsoft.com/office/drawing/2014/main" id="{DD8208FC-83C2-3DB4-987C-E51904197546}"/>
+              </a:ext>
+            </a:extLst>
+          </p:cNvPr>
+          <p:cNvSpPr/>
+          <p:nvPr/>
+        </p:nvSpPr>
+        <p:spPr>
+          <a:xfrm>
+            <a:off x="8554065" y="1622323"/>
+            <a:ext cx="2792361" cy="2969343"/>
+          </a:xfrm>
+          <a:prstGeom prst="roundRect">
+            <a:avLst/>
+          </a:prstGeom>
+        </p:spPr>
+        <p:style>
+          <a:lnRef idx="2">
+            <a:schemeClr val="accent1">
+              <a:shade val="15000"/>
+            </a:schemeClr>
+          </a:lnRef>
+          <a:fillRef idx="1">
+            <a:schemeClr val="accent1"/>
+          </a:fillRef>
+          <a:effectRef idx="0">
+            <a:schemeClr val="accent1"/>
+          </a:effectRef>
+          <a:fontRef idx="minor">
+            <a:schemeClr val="lt1"/>
+          </a:fontRef>
+        </p:style>
+        <p:txBody>
+          <a:bodyPr rtlCol="0" anchor="ctr"/>
+          <a:lstStyle/>
+          <a:p>
+            <a:pPr algn="ctr"/>
+            <a:r>
+              <a:rPr lang="en-CA" dirty="0"/>
+              <a:t>Shader “Program”</a:t>
+            </a:r>
+          </a:p>
+          <a:p>
+            <a:pPr algn="ctr"/>
+            <a:endParaRPr lang="en-CA" dirty="0"/>
+          </a:p>
+          <a:p>
+            <a:pPr algn="ctr"/>
+            <a:endParaRPr lang="en-CA" dirty="0"/>
+          </a:p>
+          <a:p>
+            <a:pPr algn="ctr"/>
+            <a:endParaRPr lang="en-CA" dirty="0"/>
+          </a:p>
+          <a:p>
+            <a:pPr algn="ctr"/>
+            <a:endParaRPr lang="en-CA" dirty="0"/>
+          </a:p>
+          <a:p>
+            <a:pPr algn="ctr"/>
+            <a:endParaRPr lang="en-CA" dirty="0"/>
+          </a:p>
+          <a:p>
+            <a:pPr algn="ctr"/>
+            <a:endParaRPr lang="en-CA" dirty="0"/>
+          </a:p>
+          <a:p>
+            <a:pPr algn="ctr"/>
+            <a:endParaRPr lang="en-CA" dirty="0"/>
+          </a:p>
+          <a:p>
+            <a:pPr algn="ctr"/>
+            <a:endParaRPr lang="en-CA" dirty="0"/>
+          </a:p>
+          <a:p>
+            <a:pPr algn="ctr"/>
+            <a:endParaRPr lang="en-CA" dirty="0"/>
+          </a:p>
+        </p:txBody>
+      </p:sp>
+      <p:sp>
+        <p:nvSpPr>
+          <p:cNvPr id="9" name="Rectangle: Rounded Corners 8">
+            <a:extLst>
+              <a:ext uri="{FF2B5EF4-FFF2-40B4-BE49-F238E27FC236}">
+                <a16:creationId xmlns:a16="http://schemas.microsoft.com/office/drawing/2014/main" id="{C770166A-DA62-5E5D-EC57-615034048C5E}"/>
+              </a:ext>
+            </a:extLst>
+          </p:cNvPr>
+          <p:cNvSpPr/>
+          <p:nvPr/>
+        </p:nvSpPr>
+        <p:spPr>
+          <a:xfrm>
+            <a:off x="9026013" y="2271253"/>
+            <a:ext cx="1986116" cy="835742"/>
+          </a:xfrm>
+          <a:prstGeom prst="roundRect">
+            <a:avLst/>
+          </a:prstGeom>
+        </p:spPr>
+        <p:style>
+          <a:lnRef idx="3">
+            <a:schemeClr val="lt1"/>
+          </a:lnRef>
+          <a:fillRef idx="1">
+            <a:schemeClr val="accent4"/>
+          </a:fillRef>
+          <a:effectRef idx="1">
+            <a:schemeClr val="accent4"/>
+          </a:effectRef>
+          <a:fontRef idx="minor">
+            <a:schemeClr val="lt1"/>
+          </a:fontRef>
+        </p:style>
+        <p:txBody>
+          <a:bodyPr rtlCol="0" anchor="ctr"/>
+          <a:lstStyle/>
+          <a:p>
+            <a:pPr algn="ctr"/>
+            <a:r>
+              <a:rPr lang="en-CA" dirty="0">
+                <a:solidFill>
+                  <a:schemeClr val="tx1"/>
+                </a:solidFill>
+              </a:rPr>
+              <a:t>Vertex</a:t>
+            </a:r>
+          </a:p>
+        </p:txBody>
+      </p:sp>
+      <p:sp>
+        <p:nvSpPr>
+          <p:cNvPr id="10" name="Rectangle: Rounded Corners 9">
+            <a:extLst>
+              <a:ext uri="{FF2B5EF4-FFF2-40B4-BE49-F238E27FC236}">
+                <a16:creationId xmlns:a16="http://schemas.microsoft.com/office/drawing/2014/main" id="{F55A8CC1-47C2-1E03-2710-00949FBA61EF}"/>
+              </a:ext>
+            </a:extLst>
+          </p:cNvPr>
+          <p:cNvSpPr/>
+          <p:nvPr/>
+        </p:nvSpPr>
+        <p:spPr>
+          <a:xfrm>
+            <a:off x="9026013" y="3298724"/>
+            <a:ext cx="1986116" cy="835742"/>
+          </a:xfrm>
+          <a:prstGeom prst="roundRect">
+            <a:avLst/>
+          </a:prstGeom>
+        </p:spPr>
+        <p:style>
+          <a:lnRef idx="3">
+            <a:schemeClr val="lt1"/>
+          </a:lnRef>
+          <a:fillRef idx="1">
+            <a:schemeClr val="accent4"/>
+          </a:fillRef>
+          <a:effectRef idx="1">
+            <a:schemeClr val="accent4"/>
+          </a:effectRef>
+          <a:fontRef idx="minor">
+            <a:schemeClr val="lt1"/>
+          </a:fontRef>
+        </p:style>
+        <p:txBody>
+          <a:bodyPr rtlCol="0" anchor="ctr"/>
+          <a:lstStyle/>
+          <a:p>
+            <a:pPr algn="ctr"/>
+            <a:r>
+              <a:rPr lang="en-CA" dirty="0">
+                <a:solidFill>
+                  <a:schemeClr val="tx1"/>
+                </a:solidFill>
+              </a:rPr>
+              <a:t>Fragment</a:t>
+            </a:r>
+          </a:p>
+        </p:txBody>
+      </p:sp>
+      <p:sp>
+        <p:nvSpPr>
+          <p:cNvPr id="12" name="Arrow: Right 11">
+            <a:extLst>
+              <a:ext uri="{FF2B5EF4-FFF2-40B4-BE49-F238E27FC236}">
+                <a16:creationId xmlns:a16="http://schemas.microsoft.com/office/drawing/2014/main" id="{A94E4D52-A290-E5D3-0494-1F5571B038C3}"/>
+              </a:ext>
+            </a:extLst>
+          </p:cNvPr>
+          <p:cNvSpPr/>
+          <p:nvPr/>
+        </p:nvSpPr>
+        <p:spPr>
+          <a:xfrm>
+            <a:off x="11611896" y="2571136"/>
+            <a:ext cx="2261420" cy="1219200"/>
+          </a:xfrm>
+          <a:prstGeom prst="rightArrow">
+            <a:avLst/>
+          </a:prstGeom>
+        </p:spPr>
+        <p:style>
+          <a:lnRef idx="1">
+            <a:schemeClr val="accent2"/>
+          </a:lnRef>
+          <a:fillRef idx="3">
+            <a:schemeClr val="accent2"/>
+          </a:fillRef>
+          <a:effectRef idx="2">
+            <a:schemeClr val="accent2"/>
+          </a:effectRef>
+          <a:fontRef idx="minor">
+            <a:schemeClr val="lt1"/>
+          </a:fontRef>
+        </p:style>
+        <p:txBody>
+          <a:bodyPr rtlCol="0" anchor="ctr"/>
+          <a:lstStyle/>
+          <a:p>
+            <a:pPr algn="ctr"/>
+            <a:r>
+              <a:rPr lang="en-CA" dirty="0"/>
+              <a:t>To the screen (back buffer)</a:t>
+            </a:r>
+          </a:p>
+        </p:txBody>
+      </p:sp>
+      <p:sp>
+        <p:nvSpPr>
+          <p:cNvPr id="14" name="Rectangle 13">
+            <a:extLst>
+              <a:ext uri="{FF2B5EF4-FFF2-40B4-BE49-F238E27FC236}">
+                <a16:creationId xmlns:a16="http://schemas.microsoft.com/office/drawing/2014/main" id="{FEF9F6F0-10D3-CC44-912C-80D329FB5F3C}"/>
+              </a:ext>
+            </a:extLst>
+          </p:cNvPr>
+          <p:cNvSpPr/>
+          <p:nvPr/>
+        </p:nvSpPr>
+        <p:spPr>
+          <a:xfrm>
+            <a:off x="29490" y="585022"/>
+            <a:ext cx="1779638" cy="2521973"/>
+          </a:xfrm>
+          <a:prstGeom prst="rect">
+            <a:avLst/>
+          </a:prstGeom>
+        </p:spPr>
+        <p:style>
+          <a:lnRef idx="3">
+            <a:schemeClr val="lt1"/>
+          </a:lnRef>
+          <a:fillRef idx="1">
+            <a:schemeClr val="accent6"/>
+          </a:fillRef>
+          <a:effectRef idx="1">
+            <a:schemeClr val="accent6"/>
+          </a:effectRef>
+          <a:fontRef idx="minor">
+            <a:schemeClr val="lt1"/>
+          </a:fontRef>
+        </p:style>
+        <p:txBody>
+          <a:bodyPr rtlCol="0" anchor="ctr"/>
+          <a:lstStyle/>
+          <a:p>
+            <a:pPr algn="ctr"/>
+            <a:r>
+              <a:rPr lang="en-CA" dirty="0"/>
+              <a:t>File</a:t>
+            </a:r>
+          </a:p>
+        </p:txBody>
+      </p:sp>
+      <p:sp>
+        <p:nvSpPr>
+          <p:cNvPr id="15" name="Arrow: Right 14">
+            <a:extLst>
+              <a:ext uri="{FF2B5EF4-FFF2-40B4-BE49-F238E27FC236}">
+                <a16:creationId xmlns:a16="http://schemas.microsoft.com/office/drawing/2014/main" id="{54854930-83AB-D2BB-035E-DDEA1FA8DE37}"/>
+              </a:ext>
+            </a:extLst>
+          </p:cNvPr>
+          <p:cNvSpPr/>
+          <p:nvPr/>
+        </p:nvSpPr>
+        <p:spPr>
+          <a:xfrm>
+            <a:off x="1334726" y="1388807"/>
+            <a:ext cx="1499418" cy="1219200"/>
+          </a:xfrm>
+          <a:prstGeom prst="rightArrow">
+            <a:avLst/>
+          </a:prstGeom>
+        </p:spPr>
+        <p:style>
+          <a:lnRef idx="1">
+            <a:schemeClr val="accent2"/>
+          </a:lnRef>
+          <a:fillRef idx="3">
+            <a:schemeClr val="accent2"/>
+          </a:fillRef>
+          <a:effectRef idx="2">
+            <a:schemeClr val="accent2"/>
+          </a:effectRef>
+          <a:fontRef idx="minor">
+            <a:schemeClr val="lt1"/>
+          </a:fontRef>
+        </p:style>
+        <p:txBody>
+          <a:bodyPr rtlCol="0" anchor="ctr"/>
+          <a:lstStyle/>
+          <a:p>
+            <a:pPr algn="ctr"/>
+            <a:endParaRPr lang="en-CA"/>
+          </a:p>
+        </p:txBody>
+      </p:sp>
+      <p:sp>
+        <p:nvSpPr>
+          <p:cNvPr id="16" name="Rectangle 15">
+            <a:extLst>
+              <a:ext uri="{FF2B5EF4-FFF2-40B4-BE49-F238E27FC236}">
+                <a16:creationId xmlns:a16="http://schemas.microsoft.com/office/drawing/2014/main" id="{AE5473DE-6B16-9DD1-C107-558517EF26D8}"/>
+              </a:ext>
+            </a:extLst>
+          </p:cNvPr>
+          <p:cNvSpPr/>
+          <p:nvPr/>
+        </p:nvSpPr>
+        <p:spPr>
+          <a:xfrm>
+            <a:off x="7280789" y="528480"/>
+            <a:ext cx="929146" cy="2863643"/>
+          </a:xfrm>
+          <a:prstGeom prst="rect">
+            <a:avLst/>
+          </a:prstGeom>
+        </p:spPr>
+        <p:style>
+          <a:lnRef idx="2">
+            <a:schemeClr val="accent4">
+              <a:shade val="15000"/>
+            </a:schemeClr>
+          </a:lnRef>
+          <a:fillRef idx="1">
+            <a:schemeClr val="accent4"/>
+          </a:fillRef>
+          <a:effectRef idx="0">
+            <a:schemeClr val="accent4"/>
+          </a:effectRef>
+          <a:fontRef idx="minor">
+            <a:schemeClr val="lt1"/>
+          </a:fontRef>
+        </p:style>
+        <p:txBody>
+          <a:bodyPr rtlCol="0" anchor="ctr"/>
+          <a:lstStyle/>
+          <a:p>
+            <a:pPr algn="ctr"/>
+            <a:r>
+              <a:rPr lang="en-CA" dirty="0"/>
+              <a:t>Index</a:t>
+            </a:r>
+          </a:p>
+          <a:p>
+            <a:pPr algn="ctr"/>
+            <a:r>
+              <a:rPr lang="en-CA" dirty="0"/>
+              <a:t>buffer</a:t>
+            </a:r>
+          </a:p>
+        </p:txBody>
+      </p:sp>
+      <p:sp>
+        <p:nvSpPr>
+          <p:cNvPr id="2" name="Rectangle 1">
+            <a:extLst>
+              <a:ext uri="{FF2B5EF4-FFF2-40B4-BE49-F238E27FC236}">
+                <a16:creationId xmlns:a16="http://schemas.microsoft.com/office/drawing/2014/main" id="{DB77F629-9FE4-9D27-A91B-F9E1EC7F6099}"/>
+              </a:ext>
+            </a:extLst>
+          </p:cNvPr>
+          <p:cNvSpPr/>
+          <p:nvPr/>
+        </p:nvSpPr>
+        <p:spPr>
+          <a:xfrm>
+            <a:off x="2841524" y="650774"/>
+            <a:ext cx="796409" cy="1619864"/>
+          </a:xfrm>
+          <a:prstGeom prst="rect">
+            <a:avLst/>
+          </a:prstGeom>
+        </p:spPr>
+        <p:style>
+          <a:lnRef idx="3">
+            <a:schemeClr val="lt1"/>
+          </a:lnRef>
+          <a:fillRef idx="1">
+            <a:schemeClr val="accent2"/>
+          </a:fillRef>
+          <a:effectRef idx="1">
+            <a:schemeClr val="accent2"/>
+          </a:effectRef>
+          <a:fontRef idx="minor">
+            <a:schemeClr val="lt1"/>
+          </a:fontRef>
+        </p:style>
+        <p:txBody>
+          <a:bodyPr rtlCol="0" anchor="ctr"/>
+          <a:lstStyle/>
+          <a:p>
+            <a:pPr algn="ctr"/>
+            <a:r>
+              <a:rPr lang="en-CA" dirty="0"/>
+              <a:t>Verts</a:t>
+            </a:r>
+          </a:p>
+        </p:txBody>
+      </p:sp>
+      <p:sp>
+        <p:nvSpPr>
+          <p:cNvPr id="3" name="Rectangle 2">
+            <a:extLst>
+              <a:ext uri="{FF2B5EF4-FFF2-40B4-BE49-F238E27FC236}">
+                <a16:creationId xmlns:a16="http://schemas.microsoft.com/office/drawing/2014/main" id="{89B9E140-32E1-9B41-9751-D0771A89CD48}"/>
+              </a:ext>
+            </a:extLst>
+          </p:cNvPr>
+          <p:cNvSpPr/>
+          <p:nvPr/>
+        </p:nvSpPr>
+        <p:spPr>
+          <a:xfrm>
+            <a:off x="2841524" y="2370804"/>
+            <a:ext cx="796409" cy="1619864"/>
+          </a:xfrm>
+          <a:prstGeom prst="rect">
+            <a:avLst/>
+          </a:prstGeom>
+        </p:spPr>
+        <p:style>
+          <a:lnRef idx="2">
+            <a:schemeClr val="accent4">
+              <a:shade val="15000"/>
+            </a:schemeClr>
+          </a:lnRef>
+          <a:fillRef idx="1">
+            <a:schemeClr val="accent4"/>
+          </a:fillRef>
+          <a:effectRef idx="0">
+            <a:schemeClr val="accent4"/>
+          </a:effectRef>
+          <a:fontRef idx="minor">
+            <a:schemeClr val="lt1"/>
+          </a:fontRef>
+        </p:style>
+        <p:txBody>
+          <a:bodyPr rtlCol="0" anchor="ctr"/>
+          <a:lstStyle/>
+          <a:p>
+            <a:pPr algn="ctr"/>
+            <a:r>
+              <a:rPr lang="en-CA" dirty="0"/>
+              <a:t>Faces</a:t>
+            </a:r>
+          </a:p>
+        </p:txBody>
+      </p:sp>
+      <p:sp>
+        <p:nvSpPr>
+          <p:cNvPr id="4" name="Rectangle 3">
+            <a:extLst>
+              <a:ext uri="{FF2B5EF4-FFF2-40B4-BE49-F238E27FC236}">
+                <a16:creationId xmlns:a16="http://schemas.microsoft.com/office/drawing/2014/main" id="{869B5C8F-E21B-CF70-3B52-020E555FD3B9}"/>
+              </a:ext>
+            </a:extLst>
+          </p:cNvPr>
+          <p:cNvSpPr/>
+          <p:nvPr/>
+        </p:nvSpPr>
+        <p:spPr>
+          <a:xfrm>
+            <a:off x="55311" y="3760837"/>
+            <a:ext cx="1779638" cy="2521973"/>
+          </a:xfrm>
+          <a:prstGeom prst="rect">
+            <a:avLst/>
+          </a:prstGeom>
+        </p:spPr>
+        <p:style>
+          <a:lnRef idx="3">
+            <a:schemeClr val="lt1"/>
+          </a:lnRef>
+          <a:fillRef idx="1">
+            <a:schemeClr val="accent6"/>
+          </a:fillRef>
+          <a:effectRef idx="1">
+            <a:schemeClr val="accent6"/>
+          </a:effectRef>
+          <a:fontRef idx="minor">
+            <a:schemeClr val="lt1"/>
+          </a:fontRef>
+        </p:style>
+        <p:txBody>
+          <a:bodyPr rtlCol="0" anchor="ctr"/>
+          <a:lstStyle/>
+          <a:p>
+            <a:pPr algn="ctr"/>
+            <a:r>
+              <a:rPr lang="en-CA" dirty="0"/>
+              <a:t>File</a:t>
+            </a:r>
+          </a:p>
+        </p:txBody>
+      </p:sp>
+      <p:sp>
+        <p:nvSpPr>
+          <p:cNvPr id="17" name="Arrow: Right 16">
+            <a:extLst>
+              <a:ext uri="{FF2B5EF4-FFF2-40B4-BE49-F238E27FC236}">
+                <a16:creationId xmlns:a16="http://schemas.microsoft.com/office/drawing/2014/main" id="{A4FC7869-B38F-8023-E9D2-9050913C2D0E}"/>
+              </a:ext>
+            </a:extLst>
+          </p:cNvPr>
+          <p:cNvSpPr/>
+          <p:nvPr/>
+        </p:nvSpPr>
+        <p:spPr>
+          <a:xfrm>
+            <a:off x="1877964" y="4490881"/>
+            <a:ext cx="1499418" cy="1219200"/>
+          </a:xfrm>
+          <a:prstGeom prst="rightArrow">
+            <a:avLst/>
+          </a:prstGeom>
+        </p:spPr>
+        <p:style>
+          <a:lnRef idx="1">
+            <a:schemeClr val="accent2"/>
+          </a:lnRef>
+          <a:fillRef idx="3">
+            <a:schemeClr val="accent2"/>
+          </a:fillRef>
+          <a:effectRef idx="2">
+            <a:schemeClr val="accent2"/>
+          </a:effectRef>
+          <a:fontRef idx="minor">
+            <a:schemeClr val="lt1"/>
+          </a:fontRef>
+        </p:style>
+        <p:txBody>
+          <a:bodyPr rtlCol="0" anchor="ctr"/>
+          <a:lstStyle/>
+          <a:p>
+            <a:pPr algn="ctr"/>
+            <a:endParaRPr lang="en-CA"/>
+          </a:p>
+        </p:txBody>
+      </p:sp>
+      <p:sp>
+        <p:nvSpPr>
+          <p:cNvPr id="18" name="Rectangle 17">
+            <a:extLst>
+              <a:ext uri="{FF2B5EF4-FFF2-40B4-BE49-F238E27FC236}">
+                <a16:creationId xmlns:a16="http://schemas.microsoft.com/office/drawing/2014/main" id="{6FB8A80E-13D5-D318-A9F4-0B9525BBA229}"/>
+              </a:ext>
+            </a:extLst>
+          </p:cNvPr>
+          <p:cNvSpPr/>
+          <p:nvPr/>
+        </p:nvSpPr>
+        <p:spPr>
+          <a:xfrm>
+            <a:off x="3384762" y="3790336"/>
+            <a:ext cx="796409" cy="1619864"/>
+          </a:xfrm>
+          <a:prstGeom prst="rect">
+            <a:avLst/>
+          </a:prstGeom>
+        </p:spPr>
+        <p:style>
+          <a:lnRef idx="3">
+            <a:schemeClr val="lt1"/>
+          </a:lnRef>
+          <a:fillRef idx="1">
+            <a:schemeClr val="accent2"/>
+          </a:fillRef>
+          <a:effectRef idx="1">
+            <a:schemeClr val="accent2"/>
+          </a:effectRef>
+          <a:fontRef idx="minor">
+            <a:schemeClr val="lt1"/>
+          </a:fontRef>
+        </p:style>
+        <p:txBody>
+          <a:bodyPr rtlCol="0" anchor="ctr"/>
+          <a:lstStyle/>
+          <a:p>
+            <a:pPr algn="ctr"/>
+            <a:r>
+              <a:rPr lang="en-CA" dirty="0"/>
+              <a:t>Verts</a:t>
+            </a:r>
+          </a:p>
+        </p:txBody>
+      </p:sp>
+      <p:sp>
+        <p:nvSpPr>
+          <p:cNvPr id="19" name="Rectangle 18">
+            <a:extLst>
+              <a:ext uri="{FF2B5EF4-FFF2-40B4-BE49-F238E27FC236}">
+                <a16:creationId xmlns:a16="http://schemas.microsoft.com/office/drawing/2014/main" id="{75156A57-602C-785F-14BA-FC54D84DCA31}"/>
+              </a:ext>
+            </a:extLst>
+          </p:cNvPr>
+          <p:cNvSpPr/>
+          <p:nvPr/>
+        </p:nvSpPr>
+        <p:spPr>
+          <a:xfrm>
+            <a:off x="3384762" y="5472878"/>
+            <a:ext cx="796409" cy="1619864"/>
+          </a:xfrm>
+          <a:prstGeom prst="rect">
+            <a:avLst/>
+          </a:prstGeom>
+        </p:spPr>
+        <p:style>
+          <a:lnRef idx="2">
+            <a:schemeClr val="accent4">
+              <a:shade val="15000"/>
+            </a:schemeClr>
+          </a:lnRef>
+          <a:fillRef idx="1">
+            <a:schemeClr val="accent4"/>
+          </a:fillRef>
+          <a:effectRef idx="0">
+            <a:schemeClr val="accent4"/>
+          </a:effectRef>
+          <a:fontRef idx="minor">
+            <a:schemeClr val="lt1"/>
+          </a:fontRef>
+        </p:style>
+        <p:txBody>
+          <a:bodyPr rtlCol="0" anchor="ctr"/>
+          <a:lstStyle/>
+          <a:p>
+            <a:pPr algn="ctr"/>
+            <a:r>
+              <a:rPr lang="en-CA" dirty="0"/>
+              <a:t>Faces</a:t>
+            </a:r>
+          </a:p>
+        </p:txBody>
+      </p:sp>
+      <p:sp>
+        <p:nvSpPr>
+          <p:cNvPr id="24" name="Rectangle 23">
+            <a:extLst>
+              <a:ext uri="{FF2B5EF4-FFF2-40B4-BE49-F238E27FC236}">
+                <a16:creationId xmlns:a16="http://schemas.microsoft.com/office/drawing/2014/main" id="{107B0D35-8CE0-1530-913C-15AF322CD2AE}"/>
+              </a:ext>
+            </a:extLst>
+          </p:cNvPr>
+          <p:cNvSpPr/>
+          <p:nvPr/>
+        </p:nvSpPr>
+        <p:spPr>
+          <a:xfrm>
+            <a:off x="6271754" y="3591239"/>
+            <a:ext cx="929146" cy="2863642"/>
+          </a:xfrm>
+          <a:prstGeom prst="rect">
+            <a:avLst/>
+          </a:prstGeom>
+        </p:spPr>
+        <p:style>
+          <a:lnRef idx="3">
+            <a:schemeClr val="lt1"/>
+          </a:lnRef>
+          <a:fillRef idx="1">
+            <a:schemeClr val="accent2"/>
+          </a:fillRef>
+          <a:effectRef idx="1">
+            <a:schemeClr val="accent2"/>
+          </a:effectRef>
+          <a:fontRef idx="minor">
+            <a:schemeClr val="lt1"/>
+          </a:fontRef>
+        </p:style>
+        <p:txBody>
+          <a:bodyPr rtlCol="0" anchor="ctr"/>
+          <a:lstStyle/>
+          <a:p>
+            <a:pPr algn="ctr"/>
+            <a:r>
+              <a:rPr lang="en-CA" dirty="0"/>
+              <a:t>Vertex</a:t>
+            </a:r>
+          </a:p>
+          <a:p>
+            <a:pPr algn="ctr"/>
+            <a:r>
+              <a:rPr lang="en-CA" dirty="0"/>
+              <a:t>buffer</a:t>
+            </a:r>
+          </a:p>
+        </p:txBody>
+      </p:sp>
+      <p:sp>
+        <p:nvSpPr>
+          <p:cNvPr id="25" name="Rectangle 24">
+            <a:extLst>
+              <a:ext uri="{FF2B5EF4-FFF2-40B4-BE49-F238E27FC236}">
+                <a16:creationId xmlns:a16="http://schemas.microsoft.com/office/drawing/2014/main" id="{1C75043D-951D-EFE6-E3AA-5E2A18D15E8E}"/>
+              </a:ext>
+            </a:extLst>
+          </p:cNvPr>
+          <p:cNvSpPr/>
+          <p:nvPr/>
+        </p:nvSpPr>
+        <p:spPr>
+          <a:xfrm>
+            <a:off x="7296766" y="3554361"/>
+            <a:ext cx="929146" cy="2863643"/>
+          </a:xfrm>
+          <a:prstGeom prst="rect">
+            <a:avLst/>
+          </a:prstGeom>
+        </p:spPr>
+        <p:style>
+          <a:lnRef idx="2">
+            <a:schemeClr val="accent4">
+              <a:shade val="15000"/>
+            </a:schemeClr>
+          </a:lnRef>
+          <a:fillRef idx="1">
+            <a:schemeClr val="accent4"/>
+          </a:fillRef>
+          <a:effectRef idx="0">
+            <a:schemeClr val="accent4"/>
+          </a:effectRef>
+          <a:fontRef idx="minor">
+            <a:schemeClr val="lt1"/>
+          </a:fontRef>
+        </p:style>
+        <p:txBody>
+          <a:bodyPr rtlCol="0" anchor="ctr"/>
+          <a:lstStyle/>
+          <a:p>
+            <a:pPr algn="ctr"/>
+            <a:r>
+              <a:rPr lang="en-CA" dirty="0"/>
+              <a:t>Index</a:t>
+            </a:r>
+          </a:p>
+          <a:p>
+            <a:pPr algn="ctr"/>
+            <a:r>
+              <a:rPr lang="en-CA" dirty="0"/>
+              <a:t>buffer</a:t>
+            </a:r>
+          </a:p>
+        </p:txBody>
+      </p:sp>
+      <p:sp>
+        <p:nvSpPr>
+          <p:cNvPr id="13" name="Arrow: Right 12">
+            <a:extLst>
+              <a:ext uri="{FF2B5EF4-FFF2-40B4-BE49-F238E27FC236}">
+                <a16:creationId xmlns:a16="http://schemas.microsoft.com/office/drawing/2014/main" id="{5F240329-D1AC-2AA6-9E5F-9F28FBD8DB21}"/>
+              </a:ext>
+            </a:extLst>
+          </p:cNvPr>
+          <p:cNvSpPr/>
+          <p:nvPr/>
+        </p:nvSpPr>
+        <p:spPr>
+          <a:xfrm>
+            <a:off x="7831390" y="1814053"/>
+            <a:ext cx="1194623" cy="1219200"/>
+          </a:xfrm>
+          <a:prstGeom prst="rightArrow">
+            <a:avLst/>
+          </a:prstGeom>
+        </p:spPr>
+        <p:style>
+          <a:lnRef idx="1">
+            <a:schemeClr val="accent2"/>
+          </a:lnRef>
+          <a:fillRef idx="3">
+            <a:schemeClr val="accent2"/>
+          </a:fillRef>
+          <a:effectRef idx="2">
+            <a:schemeClr val="accent2"/>
+          </a:effectRef>
+          <a:fontRef idx="minor">
+            <a:schemeClr val="lt1"/>
+          </a:fontRef>
+        </p:style>
+        <p:txBody>
+          <a:bodyPr rtlCol="0" anchor="ctr"/>
+          <a:lstStyle/>
+          <a:p>
+            <a:pPr algn="ctr"/>
+            <a:endParaRPr lang="en-CA"/>
+          </a:p>
+        </p:txBody>
+      </p:sp>
+      <p:sp>
+        <p:nvSpPr>
+          <p:cNvPr id="26" name="Rectangle 25">
+            <a:extLst>
+              <a:ext uri="{FF2B5EF4-FFF2-40B4-BE49-F238E27FC236}">
+                <a16:creationId xmlns:a16="http://schemas.microsoft.com/office/drawing/2014/main" id="{531FE970-6267-F244-17E0-4D3A7A538603}"/>
+              </a:ext>
+            </a:extLst>
+          </p:cNvPr>
+          <p:cNvSpPr/>
+          <p:nvPr/>
+        </p:nvSpPr>
+        <p:spPr>
+          <a:xfrm>
+            <a:off x="3782966" y="637868"/>
+            <a:ext cx="796409" cy="1619864"/>
+          </a:xfrm>
+          <a:prstGeom prst="rect">
+            <a:avLst/>
+          </a:prstGeom>
+        </p:spPr>
+        <p:style>
+          <a:lnRef idx="3">
+            <a:schemeClr val="lt1"/>
+          </a:lnRef>
+          <a:fillRef idx="1">
+            <a:schemeClr val="accent2"/>
+          </a:fillRef>
+          <a:effectRef idx="1">
+            <a:schemeClr val="accent2"/>
+          </a:effectRef>
+          <a:fontRef idx="minor">
+            <a:schemeClr val="lt1"/>
+          </a:fontRef>
+        </p:style>
+        <p:txBody>
+          <a:bodyPr rtlCol="0" anchor="ctr"/>
+          <a:lstStyle/>
+          <a:p>
+            <a:pPr algn="ctr"/>
+            <a:r>
+              <a:rPr lang="en-CA" dirty="0"/>
+              <a:t>Verts</a:t>
+            </a:r>
+          </a:p>
+        </p:txBody>
+      </p:sp>
+    </p:spTree>
+    <p:extLst>
+      <p:ext uri="{BB962C8B-B14F-4D97-AF65-F5344CB8AC3E}">
+        <p14:creationId xmlns:p14="http://schemas.microsoft.com/office/powerpoint/2010/main" val="1181421529"/>
+      </p:ext>
+    </p:extLst>
+  </p:cSld>
+  <p:clrMapOvr>
+    <a:masterClrMapping/>
+  </p:clrMapOvr>
+</p:sld>
+</file>
+
+<file path=ppt/slides/slide5.xml><?xml version="1.0" encoding="utf-8"?>
+<p:sld xmlns:a="http://schemas.openxmlformats.org/drawingml/2006/main" xmlns:r="http://schemas.openxmlformats.org/officeDocument/2006/relationships" xmlns:p="http://schemas.openxmlformats.org/presentationml/2006/main">
+  <p:cSld>
+    <p:spTree>
+      <p:nvGrpSpPr>
+        <p:cNvPr id="1" name=""/>
+        <p:cNvGrpSpPr/>
+        <p:nvPr/>
+      </p:nvGrpSpPr>
+      <p:grpSpPr>
+        <a:xfrm>
+          <a:off x="0" y="0"/>
+          <a:ext cx="0" cy="0"/>
+          <a:chOff x="0" y="0"/>
+          <a:chExt cx="0" cy="0"/>
+        </a:xfrm>
+      </p:grpSpPr>
+      <p:sp>
+        <p:nvSpPr>
+          <p:cNvPr id="5" name="Rectangle: Rounded Corners 4">
+            <a:extLst>
+              <a:ext uri="{FF2B5EF4-FFF2-40B4-BE49-F238E27FC236}">
+                <a16:creationId xmlns:a16="http://schemas.microsoft.com/office/drawing/2014/main" id="{855FD758-8CA8-97F0-86A6-673795C8D55E}"/>
+              </a:ext>
+            </a:extLst>
+          </p:cNvPr>
+          <p:cNvSpPr/>
+          <p:nvPr/>
+        </p:nvSpPr>
+        <p:spPr>
+          <a:xfrm>
+            <a:off x="2185220" y="39336"/>
+            <a:ext cx="3470788" cy="6459794"/>
+          </a:xfrm>
+          <a:prstGeom prst="roundRect">
+            <a:avLst/>
+          </a:prstGeom>
+        </p:spPr>
+        <p:style>
+          <a:lnRef idx="2">
+            <a:schemeClr val="accent1">
+              <a:shade val="15000"/>
+            </a:schemeClr>
+          </a:lnRef>
+          <a:fillRef idx="1">
+            <a:schemeClr val="accent1"/>
+          </a:fillRef>
+          <a:effectRef idx="0">
+            <a:schemeClr val="accent1"/>
+          </a:effectRef>
+          <a:fontRef idx="minor">
+            <a:schemeClr val="lt1"/>
+          </a:fontRef>
+        </p:style>
+        <p:txBody>
+          <a:bodyPr rtlCol="0" anchor="ctr"/>
+          <a:lstStyle/>
+          <a:p>
+            <a:pPr algn="ctr"/>
+            <a:r>
+              <a:rPr lang="en-CA" dirty="0"/>
+              <a:t>CPU (C++)</a:t>
+            </a:r>
+          </a:p>
+          <a:p>
+            <a:pPr algn="ctr"/>
+            <a:endParaRPr lang="en-CA" dirty="0"/>
+          </a:p>
+          <a:p>
+            <a:pPr algn="ctr"/>
+            <a:endParaRPr lang="en-CA" dirty="0"/>
+          </a:p>
+          <a:p>
+            <a:pPr algn="ctr"/>
+            <a:endParaRPr lang="en-CA" dirty="0"/>
+          </a:p>
+          <a:p>
+            <a:pPr algn="ctr"/>
+            <a:endParaRPr lang="en-CA" dirty="0"/>
+          </a:p>
+          <a:p>
+            <a:pPr algn="ctr"/>
+            <a:endParaRPr lang="en-CA" dirty="0"/>
+          </a:p>
+          <a:p>
+            <a:pPr algn="ctr"/>
+            <a:endParaRPr lang="en-CA" dirty="0"/>
+          </a:p>
+          <a:p>
+            <a:pPr algn="ctr"/>
+            <a:endParaRPr lang="en-CA" dirty="0"/>
+          </a:p>
+          <a:p>
+            <a:pPr algn="ctr"/>
+            <a:endParaRPr lang="en-CA" dirty="0"/>
+          </a:p>
+          <a:p>
+            <a:pPr algn="ctr"/>
+            <a:endParaRPr lang="en-CA" dirty="0"/>
+          </a:p>
+          <a:p>
+            <a:pPr algn="ctr"/>
+            <a:endParaRPr lang="en-CA" dirty="0"/>
+          </a:p>
+          <a:p>
+            <a:pPr algn="ctr"/>
+            <a:endParaRPr lang="en-CA" dirty="0"/>
+          </a:p>
+          <a:p>
+            <a:pPr algn="ctr"/>
+            <a:endParaRPr lang="en-CA" dirty="0"/>
+          </a:p>
+          <a:p>
+            <a:pPr algn="ctr"/>
+            <a:endParaRPr lang="en-CA" dirty="0"/>
+          </a:p>
+          <a:p>
+            <a:pPr algn="ctr"/>
+            <a:endParaRPr lang="en-CA" dirty="0"/>
+          </a:p>
+          <a:p>
+            <a:pPr algn="ctr"/>
+            <a:endParaRPr lang="en-CA" dirty="0"/>
+          </a:p>
+          <a:p>
+            <a:pPr algn="ctr"/>
+            <a:endParaRPr lang="en-CA" dirty="0"/>
+          </a:p>
+          <a:p>
+            <a:pPr algn="ctr"/>
+            <a:endParaRPr lang="en-CA" dirty="0"/>
+          </a:p>
+        </p:txBody>
+      </p:sp>
+      <p:sp>
+        <p:nvSpPr>
+          <p:cNvPr id="6" name="Rectangle: Rounded Corners 5">
+            <a:extLst>
+              <a:ext uri="{FF2B5EF4-FFF2-40B4-BE49-F238E27FC236}">
+                <a16:creationId xmlns:a16="http://schemas.microsoft.com/office/drawing/2014/main" id="{A7AB6A8E-617B-EFE7-82EB-41E6C14BB692}"/>
+              </a:ext>
+            </a:extLst>
+          </p:cNvPr>
+          <p:cNvSpPr/>
+          <p:nvPr/>
+        </p:nvSpPr>
+        <p:spPr>
+          <a:xfrm>
+            <a:off x="6130413" y="56553"/>
+            <a:ext cx="5309418" cy="6459794"/>
+          </a:xfrm>
+          <a:prstGeom prst="roundRect">
+            <a:avLst/>
+          </a:prstGeom>
+        </p:spPr>
+        <p:style>
+          <a:lnRef idx="2">
+            <a:schemeClr val="accent1">
+              <a:shade val="15000"/>
+            </a:schemeClr>
+          </a:lnRef>
+          <a:fillRef idx="1">
+            <a:schemeClr val="accent1"/>
+          </a:fillRef>
+          <a:effectRef idx="0">
+            <a:schemeClr val="accent1"/>
+          </a:effectRef>
+          <a:fontRef idx="minor">
+            <a:schemeClr val="lt1"/>
+          </a:fontRef>
+        </p:style>
+        <p:txBody>
+          <a:bodyPr rtlCol="0" anchor="ctr"/>
+          <a:lstStyle/>
+          <a:p>
+            <a:pPr algn="ctr"/>
+            <a:r>
+              <a:rPr lang="en-CA" dirty="0"/>
+              <a:t>GPU</a:t>
+            </a:r>
+          </a:p>
+          <a:p>
+            <a:pPr algn="ctr"/>
+            <a:endParaRPr lang="en-CA" dirty="0"/>
+          </a:p>
+          <a:p>
+            <a:pPr algn="ctr"/>
+            <a:endParaRPr lang="en-CA" dirty="0"/>
+          </a:p>
+          <a:p>
+            <a:pPr algn="ctr"/>
+            <a:endParaRPr lang="en-CA" dirty="0"/>
+          </a:p>
+          <a:p>
+            <a:pPr algn="ctr"/>
+            <a:endParaRPr lang="en-CA" dirty="0"/>
+          </a:p>
+          <a:p>
+            <a:pPr algn="ctr"/>
+            <a:endParaRPr lang="en-CA" dirty="0"/>
+          </a:p>
+          <a:p>
+            <a:pPr algn="ctr"/>
+            <a:endParaRPr lang="en-CA" dirty="0"/>
+          </a:p>
+          <a:p>
+            <a:pPr algn="ctr"/>
+            <a:endParaRPr lang="en-CA" dirty="0"/>
+          </a:p>
+          <a:p>
+            <a:pPr algn="ctr"/>
+            <a:endParaRPr lang="en-CA" dirty="0"/>
+          </a:p>
+          <a:p>
+            <a:pPr algn="ctr"/>
+            <a:endParaRPr lang="en-CA" dirty="0"/>
+          </a:p>
+          <a:p>
+            <a:pPr algn="ctr"/>
+            <a:endParaRPr lang="en-CA" dirty="0"/>
+          </a:p>
+          <a:p>
+            <a:pPr algn="ctr"/>
+            <a:endParaRPr lang="en-CA" dirty="0"/>
+          </a:p>
+          <a:p>
+            <a:pPr algn="ctr"/>
+            <a:endParaRPr lang="en-CA" dirty="0"/>
+          </a:p>
+          <a:p>
+            <a:pPr algn="ctr"/>
+            <a:endParaRPr lang="en-CA" dirty="0"/>
+          </a:p>
+          <a:p>
+            <a:pPr algn="ctr"/>
+            <a:endParaRPr lang="en-CA" dirty="0"/>
+          </a:p>
+          <a:p>
+            <a:pPr algn="ctr"/>
+            <a:endParaRPr lang="en-CA" dirty="0"/>
+          </a:p>
+          <a:p>
+            <a:pPr algn="ctr"/>
+            <a:endParaRPr lang="en-CA" dirty="0"/>
+          </a:p>
+          <a:p>
+            <a:pPr algn="ctr"/>
+            <a:endParaRPr lang="en-CA" dirty="0"/>
+          </a:p>
+        </p:txBody>
+      </p:sp>
+      <p:sp>
+        <p:nvSpPr>
+          <p:cNvPr id="7" name="Rectangle 6">
+            <a:extLst>
+              <a:ext uri="{FF2B5EF4-FFF2-40B4-BE49-F238E27FC236}">
+                <a16:creationId xmlns:a16="http://schemas.microsoft.com/office/drawing/2014/main" id="{A0A7DBA7-1C8E-1277-B21A-295B2BF3A4E4}"/>
+              </a:ext>
+            </a:extLst>
+          </p:cNvPr>
+          <p:cNvSpPr/>
+          <p:nvPr/>
+        </p:nvSpPr>
+        <p:spPr>
+          <a:xfrm>
+            <a:off x="6700699" y="557983"/>
+            <a:ext cx="929146" cy="2863642"/>
+          </a:xfrm>
+          <a:prstGeom prst="rect">
+            <a:avLst/>
+          </a:prstGeom>
+        </p:spPr>
+        <p:style>
+          <a:lnRef idx="3">
+            <a:schemeClr val="lt1"/>
+          </a:lnRef>
+          <a:fillRef idx="1">
+            <a:schemeClr val="accent2"/>
+          </a:fillRef>
+          <a:effectRef idx="1">
+            <a:schemeClr val="accent2"/>
+          </a:effectRef>
+          <a:fontRef idx="minor">
+            <a:schemeClr val="lt1"/>
+          </a:fontRef>
+        </p:style>
+        <p:txBody>
+          <a:bodyPr rtlCol="0" anchor="ctr"/>
+          <a:lstStyle/>
+          <a:p>
+            <a:pPr algn="ctr"/>
+            <a:r>
+              <a:rPr lang="en-CA" dirty="0"/>
+              <a:t>Vertex</a:t>
+            </a:r>
+          </a:p>
+          <a:p>
+            <a:pPr algn="ctr"/>
+            <a:r>
+              <a:rPr lang="en-CA" dirty="0"/>
+              <a:t>buffer</a:t>
+            </a:r>
+          </a:p>
+        </p:txBody>
+      </p:sp>
+      <p:sp>
+        <p:nvSpPr>
+          <p:cNvPr id="8" name="Arrow: Right 7">
+            <a:extLst>
+              <a:ext uri="{FF2B5EF4-FFF2-40B4-BE49-F238E27FC236}">
+                <a16:creationId xmlns:a16="http://schemas.microsoft.com/office/drawing/2014/main" id="{9E9D5935-7A52-C77B-8374-E864BCEE7462}"/>
+              </a:ext>
+            </a:extLst>
+          </p:cNvPr>
+          <p:cNvSpPr/>
+          <p:nvPr/>
+        </p:nvSpPr>
+        <p:spPr>
+          <a:xfrm>
+            <a:off x="3293805" y="1607579"/>
+            <a:ext cx="1282480" cy="1219200"/>
+          </a:xfrm>
+          <a:prstGeom prst="rightArrow">
+            <a:avLst/>
+          </a:prstGeom>
+        </p:spPr>
+        <p:style>
+          <a:lnRef idx="1">
+            <a:schemeClr val="accent2"/>
+          </a:lnRef>
+          <a:fillRef idx="3">
+            <a:schemeClr val="accent2"/>
+          </a:fillRef>
+          <a:effectRef idx="2">
+            <a:schemeClr val="accent2"/>
+          </a:effectRef>
+          <a:fontRef idx="minor">
+            <a:schemeClr val="lt1"/>
+          </a:fontRef>
+        </p:style>
+        <p:txBody>
+          <a:bodyPr rtlCol="0" anchor="ctr"/>
+          <a:lstStyle/>
+          <a:p>
+            <a:pPr algn="ctr"/>
+            <a:endParaRPr lang="en-CA" dirty="0"/>
+          </a:p>
+        </p:txBody>
+      </p:sp>
+      <p:sp>
+        <p:nvSpPr>
+          <p:cNvPr id="11" name="Rectangle: Rounded Corners 10">
+            <a:extLst>
+              <a:ext uri="{FF2B5EF4-FFF2-40B4-BE49-F238E27FC236}">
+                <a16:creationId xmlns:a16="http://schemas.microsoft.com/office/drawing/2014/main" id="{DD8208FC-83C2-3DB4-987C-E51904197546}"/>
+              </a:ext>
+            </a:extLst>
+          </p:cNvPr>
+          <p:cNvSpPr/>
+          <p:nvPr/>
+        </p:nvSpPr>
+        <p:spPr>
+          <a:xfrm>
+            <a:off x="8899423" y="1568249"/>
+            <a:ext cx="2792361" cy="2969343"/>
+          </a:xfrm>
+          <a:prstGeom prst="roundRect">
+            <a:avLst/>
+          </a:prstGeom>
+        </p:spPr>
+        <p:style>
+          <a:lnRef idx="2">
+            <a:schemeClr val="accent1">
+              <a:shade val="15000"/>
+            </a:schemeClr>
+          </a:lnRef>
+          <a:fillRef idx="1">
+            <a:schemeClr val="accent1"/>
+          </a:fillRef>
+          <a:effectRef idx="0">
+            <a:schemeClr val="accent1"/>
+          </a:effectRef>
+          <a:fontRef idx="minor">
+            <a:schemeClr val="lt1"/>
+          </a:fontRef>
+        </p:style>
+        <p:txBody>
+          <a:bodyPr rtlCol="0" anchor="ctr"/>
+          <a:lstStyle/>
+          <a:p>
+            <a:pPr algn="ctr"/>
+            <a:r>
+              <a:rPr lang="en-CA" dirty="0"/>
+              <a:t>Shader “Program”</a:t>
+            </a:r>
+          </a:p>
+          <a:p>
+            <a:pPr algn="ctr"/>
+            <a:endParaRPr lang="en-CA" dirty="0"/>
+          </a:p>
+          <a:p>
+            <a:pPr algn="ctr"/>
+            <a:endParaRPr lang="en-CA" dirty="0"/>
+          </a:p>
+          <a:p>
+            <a:pPr algn="ctr"/>
+            <a:endParaRPr lang="en-CA" dirty="0"/>
+          </a:p>
+          <a:p>
+            <a:pPr algn="ctr"/>
+            <a:endParaRPr lang="en-CA" dirty="0"/>
+          </a:p>
+          <a:p>
+            <a:pPr algn="ctr"/>
+            <a:endParaRPr lang="en-CA" dirty="0"/>
+          </a:p>
+          <a:p>
+            <a:pPr algn="ctr"/>
+            <a:endParaRPr lang="en-CA" dirty="0"/>
+          </a:p>
+          <a:p>
+            <a:pPr algn="ctr"/>
+            <a:endParaRPr lang="en-CA" dirty="0"/>
+          </a:p>
+          <a:p>
+            <a:pPr algn="ctr"/>
+            <a:endParaRPr lang="en-CA" dirty="0"/>
+          </a:p>
+          <a:p>
+            <a:pPr algn="ctr"/>
+            <a:endParaRPr lang="en-CA" dirty="0"/>
+          </a:p>
+        </p:txBody>
+      </p:sp>
+      <p:sp>
+        <p:nvSpPr>
+          <p:cNvPr id="9" name="Rectangle: Rounded Corners 8">
+            <a:extLst>
+              <a:ext uri="{FF2B5EF4-FFF2-40B4-BE49-F238E27FC236}">
+                <a16:creationId xmlns:a16="http://schemas.microsoft.com/office/drawing/2014/main" id="{C770166A-DA62-5E5D-EC57-615034048C5E}"/>
+              </a:ext>
+            </a:extLst>
+          </p:cNvPr>
+          <p:cNvSpPr/>
+          <p:nvPr/>
+        </p:nvSpPr>
+        <p:spPr>
+          <a:xfrm>
+            <a:off x="9371371" y="2217179"/>
+            <a:ext cx="1986116" cy="835742"/>
+          </a:xfrm>
+          <a:prstGeom prst="roundRect">
+            <a:avLst/>
+          </a:prstGeom>
+        </p:spPr>
+        <p:style>
+          <a:lnRef idx="3">
+            <a:schemeClr val="lt1"/>
+          </a:lnRef>
+          <a:fillRef idx="1">
+            <a:schemeClr val="accent4"/>
+          </a:fillRef>
+          <a:effectRef idx="1">
+            <a:schemeClr val="accent4"/>
+          </a:effectRef>
+          <a:fontRef idx="minor">
+            <a:schemeClr val="lt1"/>
+          </a:fontRef>
+        </p:style>
+        <p:txBody>
+          <a:bodyPr rtlCol="0" anchor="ctr"/>
+          <a:lstStyle/>
+          <a:p>
+            <a:pPr algn="ctr"/>
+            <a:r>
+              <a:rPr lang="en-CA" dirty="0">
+                <a:solidFill>
+                  <a:schemeClr val="tx1"/>
+                </a:solidFill>
+              </a:rPr>
+              <a:t>Vertex</a:t>
+            </a:r>
+          </a:p>
+        </p:txBody>
+      </p:sp>
+      <p:sp>
+        <p:nvSpPr>
+          <p:cNvPr id="10" name="Rectangle: Rounded Corners 9">
+            <a:extLst>
+              <a:ext uri="{FF2B5EF4-FFF2-40B4-BE49-F238E27FC236}">
+                <a16:creationId xmlns:a16="http://schemas.microsoft.com/office/drawing/2014/main" id="{F55A8CC1-47C2-1E03-2710-00949FBA61EF}"/>
+              </a:ext>
+            </a:extLst>
+          </p:cNvPr>
+          <p:cNvSpPr/>
+          <p:nvPr/>
+        </p:nvSpPr>
+        <p:spPr>
+          <a:xfrm>
+            <a:off x="9371371" y="3244650"/>
+            <a:ext cx="1986116" cy="835742"/>
+          </a:xfrm>
+          <a:prstGeom prst="roundRect">
+            <a:avLst/>
+          </a:prstGeom>
+        </p:spPr>
+        <p:style>
+          <a:lnRef idx="3">
+            <a:schemeClr val="lt1"/>
+          </a:lnRef>
+          <a:fillRef idx="1">
+            <a:schemeClr val="accent4"/>
+          </a:fillRef>
+          <a:effectRef idx="1">
+            <a:schemeClr val="accent4"/>
+          </a:effectRef>
+          <a:fontRef idx="minor">
+            <a:schemeClr val="lt1"/>
+          </a:fontRef>
+        </p:style>
+        <p:txBody>
+          <a:bodyPr rtlCol="0" anchor="ctr"/>
+          <a:lstStyle/>
+          <a:p>
+            <a:pPr algn="ctr"/>
+            <a:r>
+              <a:rPr lang="en-CA" dirty="0">
+                <a:solidFill>
+                  <a:schemeClr val="tx1"/>
+                </a:solidFill>
+              </a:rPr>
+              <a:t>Fragment</a:t>
+            </a:r>
+          </a:p>
+        </p:txBody>
+      </p:sp>
+      <p:sp>
+        <p:nvSpPr>
+          <p:cNvPr id="12" name="Arrow: Right 11">
+            <a:extLst>
+              <a:ext uri="{FF2B5EF4-FFF2-40B4-BE49-F238E27FC236}">
+                <a16:creationId xmlns:a16="http://schemas.microsoft.com/office/drawing/2014/main" id="{A94E4D52-A290-E5D3-0494-1F5571B038C3}"/>
+              </a:ext>
+            </a:extLst>
+          </p:cNvPr>
+          <p:cNvSpPr/>
+          <p:nvPr/>
+        </p:nvSpPr>
+        <p:spPr>
+          <a:xfrm>
+            <a:off x="11611896" y="2571136"/>
+            <a:ext cx="2261420" cy="1219200"/>
+          </a:xfrm>
+          <a:prstGeom prst="rightArrow">
+            <a:avLst/>
+          </a:prstGeom>
+        </p:spPr>
+        <p:style>
+          <a:lnRef idx="1">
+            <a:schemeClr val="accent2"/>
+          </a:lnRef>
+          <a:fillRef idx="3">
+            <a:schemeClr val="accent2"/>
+          </a:fillRef>
+          <a:effectRef idx="2">
+            <a:schemeClr val="accent2"/>
+          </a:effectRef>
+          <a:fontRef idx="minor">
+            <a:schemeClr val="lt1"/>
+          </a:fontRef>
+        </p:style>
+        <p:txBody>
+          <a:bodyPr rtlCol="0" anchor="ctr"/>
+          <a:lstStyle/>
+          <a:p>
+            <a:pPr algn="ctr"/>
+            <a:r>
+              <a:rPr lang="en-CA" dirty="0"/>
+              <a:t>To the screen (back buffer)</a:t>
+            </a:r>
+          </a:p>
+        </p:txBody>
+      </p:sp>
+      <p:sp>
+        <p:nvSpPr>
+          <p:cNvPr id="14" name="Rectangle 13">
+            <a:extLst>
+              <a:ext uri="{FF2B5EF4-FFF2-40B4-BE49-F238E27FC236}">
+                <a16:creationId xmlns:a16="http://schemas.microsoft.com/office/drawing/2014/main" id="{FEF9F6F0-10D3-CC44-912C-80D329FB5F3C}"/>
+              </a:ext>
+            </a:extLst>
+          </p:cNvPr>
+          <p:cNvSpPr/>
+          <p:nvPr/>
+        </p:nvSpPr>
+        <p:spPr>
+          <a:xfrm>
+            <a:off x="0" y="913170"/>
+            <a:ext cx="1337194" cy="1986114"/>
+          </a:xfrm>
+          <a:prstGeom prst="rect">
+            <a:avLst/>
+          </a:prstGeom>
+        </p:spPr>
+        <p:style>
+          <a:lnRef idx="3">
+            <a:schemeClr val="lt1"/>
+          </a:lnRef>
+          <a:fillRef idx="1">
+            <a:schemeClr val="accent6"/>
+          </a:fillRef>
+          <a:effectRef idx="1">
+            <a:schemeClr val="accent6"/>
+          </a:effectRef>
+          <a:fontRef idx="minor">
+            <a:schemeClr val="lt1"/>
+          </a:fontRef>
+        </p:style>
+        <p:txBody>
+          <a:bodyPr rtlCol="0" anchor="ctr"/>
+          <a:lstStyle/>
+          <a:p>
+            <a:pPr algn="ctr"/>
+            <a:r>
+              <a:rPr lang="en-CA" dirty="0"/>
+              <a:t>File</a:t>
+            </a:r>
+          </a:p>
+        </p:txBody>
+      </p:sp>
+      <p:sp>
+        <p:nvSpPr>
+          <p:cNvPr id="15" name="Arrow: Right 14">
+            <a:extLst>
+              <a:ext uri="{FF2B5EF4-FFF2-40B4-BE49-F238E27FC236}">
+                <a16:creationId xmlns:a16="http://schemas.microsoft.com/office/drawing/2014/main" id="{54854930-83AB-D2BB-035E-DDEA1FA8DE37}"/>
+              </a:ext>
+            </a:extLst>
+          </p:cNvPr>
+          <p:cNvSpPr/>
+          <p:nvPr/>
+        </p:nvSpPr>
+        <p:spPr>
+          <a:xfrm>
+            <a:off x="1123938" y="1496959"/>
+            <a:ext cx="1337194" cy="1219200"/>
+          </a:xfrm>
+          <a:prstGeom prst="rightArrow">
+            <a:avLst/>
+          </a:prstGeom>
+        </p:spPr>
+        <p:style>
+          <a:lnRef idx="1">
+            <a:schemeClr val="accent2"/>
+          </a:lnRef>
+          <a:fillRef idx="3">
+            <a:schemeClr val="accent2"/>
+          </a:fillRef>
+          <a:effectRef idx="2">
+            <a:schemeClr val="accent2"/>
+          </a:effectRef>
+          <a:fontRef idx="minor">
+            <a:schemeClr val="lt1"/>
+          </a:fontRef>
+        </p:style>
+        <p:txBody>
+          <a:bodyPr rtlCol="0" anchor="ctr"/>
+          <a:lstStyle/>
+          <a:p>
+            <a:pPr algn="ctr"/>
+            <a:endParaRPr lang="en-CA"/>
+          </a:p>
+        </p:txBody>
+      </p:sp>
+      <p:sp>
+        <p:nvSpPr>
+          <p:cNvPr id="16" name="Rectangle 15">
+            <a:extLst>
+              <a:ext uri="{FF2B5EF4-FFF2-40B4-BE49-F238E27FC236}">
+                <a16:creationId xmlns:a16="http://schemas.microsoft.com/office/drawing/2014/main" id="{AE5473DE-6B16-9DD1-C107-558517EF26D8}"/>
+              </a:ext>
+            </a:extLst>
+          </p:cNvPr>
+          <p:cNvSpPr/>
+          <p:nvPr/>
+        </p:nvSpPr>
+        <p:spPr>
+          <a:xfrm>
+            <a:off x="7734303" y="548135"/>
+            <a:ext cx="929146" cy="2863643"/>
+          </a:xfrm>
+          <a:prstGeom prst="rect">
+            <a:avLst/>
+          </a:prstGeom>
+        </p:spPr>
+        <p:style>
+          <a:lnRef idx="2">
+            <a:schemeClr val="accent4">
+              <a:shade val="15000"/>
+            </a:schemeClr>
+          </a:lnRef>
+          <a:fillRef idx="1">
+            <a:schemeClr val="accent4"/>
+          </a:fillRef>
+          <a:effectRef idx="0">
+            <a:schemeClr val="accent4"/>
+          </a:effectRef>
+          <a:fontRef idx="minor">
+            <a:schemeClr val="lt1"/>
+          </a:fontRef>
+        </p:style>
+        <p:txBody>
+          <a:bodyPr rtlCol="0" anchor="ctr"/>
+          <a:lstStyle/>
+          <a:p>
+            <a:pPr algn="ctr"/>
+            <a:r>
+              <a:rPr lang="en-CA" dirty="0"/>
+              <a:t>Index</a:t>
+            </a:r>
+          </a:p>
+          <a:p>
+            <a:pPr algn="ctr"/>
+            <a:r>
+              <a:rPr lang="en-CA" dirty="0"/>
+              <a:t>buffer</a:t>
+            </a:r>
+          </a:p>
+        </p:txBody>
+      </p:sp>
+      <p:sp>
+        <p:nvSpPr>
+          <p:cNvPr id="2" name="Rectangle 1">
+            <a:extLst>
+              <a:ext uri="{FF2B5EF4-FFF2-40B4-BE49-F238E27FC236}">
+                <a16:creationId xmlns:a16="http://schemas.microsoft.com/office/drawing/2014/main" id="{DB77F629-9FE4-9D27-A91B-F9E1EC7F6099}"/>
+              </a:ext>
+            </a:extLst>
+          </p:cNvPr>
+          <p:cNvSpPr/>
+          <p:nvPr/>
+        </p:nvSpPr>
+        <p:spPr>
+          <a:xfrm>
+            <a:off x="2304745" y="1206915"/>
+            <a:ext cx="951266" cy="1619864"/>
+          </a:xfrm>
+          <a:prstGeom prst="rect">
+            <a:avLst/>
+          </a:prstGeom>
+        </p:spPr>
+        <p:style>
+          <a:lnRef idx="3">
+            <a:schemeClr val="lt1"/>
+          </a:lnRef>
+          <a:fillRef idx="1">
+            <a:schemeClr val="accent2"/>
+          </a:fillRef>
+          <a:effectRef idx="1">
+            <a:schemeClr val="accent2"/>
+          </a:effectRef>
+          <a:fontRef idx="minor">
+            <a:schemeClr val="lt1"/>
+          </a:fontRef>
+        </p:style>
+        <p:txBody>
+          <a:bodyPr rtlCol="0" anchor="ctr"/>
+          <a:lstStyle/>
+          <a:p>
+            <a:pPr algn="ctr"/>
+            <a:r>
+              <a:rPr lang="en-CA" dirty="0"/>
+              <a:t>Verts in file</a:t>
+            </a:r>
+          </a:p>
+        </p:txBody>
+      </p:sp>
+      <p:sp>
+        <p:nvSpPr>
+          <p:cNvPr id="24" name="Rectangle 23">
+            <a:extLst>
+              <a:ext uri="{FF2B5EF4-FFF2-40B4-BE49-F238E27FC236}">
+                <a16:creationId xmlns:a16="http://schemas.microsoft.com/office/drawing/2014/main" id="{107B0D35-8CE0-1530-913C-15AF322CD2AE}"/>
+              </a:ext>
+            </a:extLst>
+          </p:cNvPr>
+          <p:cNvSpPr/>
+          <p:nvPr/>
+        </p:nvSpPr>
+        <p:spPr>
+          <a:xfrm>
+            <a:off x="6617112" y="3537165"/>
+            <a:ext cx="929146" cy="2863642"/>
+          </a:xfrm>
+          <a:prstGeom prst="rect">
+            <a:avLst/>
+          </a:prstGeom>
+        </p:spPr>
+        <p:style>
+          <a:lnRef idx="3">
+            <a:schemeClr val="lt1"/>
+          </a:lnRef>
+          <a:fillRef idx="1">
+            <a:schemeClr val="accent2"/>
+          </a:fillRef>
+          <a:effectRef idx="1">
+            <a:schemeClr val="accent2"/>
+          </a:effectRef>
+          <a:fontRef idx="minor">
+            <a:schemeClr val="lt1"/>
+          </a:fontRef>
+        </p:style>
+        <p:txBody>
+          <a:bodyPr rtlCol="0" anchor="ctr"/>
+          <a:lstStyle/>
+          <a:p>
+            <a:pPr algn="ctr"/>
+            <a:r>
+              <a:rPr lang="en-CA" dirty="0"/>
+              <a:t>Vertex</a:t>
+            </a:r>
+          </a:p>
+          <a:p>
+            <a:pPr algn="ctr"/>
+            <a:r>
+              <a:rPr lang="en-CA" dirty="0"/>
+              <a:t>buffer</a:t>
+            </a:r>
+          </a:p>
+        </p:txBody>
+      </p:sp>
+      <p:sp>
+        <p:nvSpPr>
+          <p:cNvPr id="25" name="Rectangle 24">
+            <a:extLst>
+              <a:ext uri="{FF2B5EF4-FFF2-40B4-BE49-F238E27FC236}">
+                <a16:creationId xmlns:a16="http://schemas.microsoft.com/office/drawing/2014/main" id="{1C75043D-951D-EFE6-E3AA-5E2A18D15E8E}"/>
+              </a:ext>
+            </a:extLst>
+          </p:cNvPr>
+          <p:cNvSpPr/>
+          <p:nvPr/>
+        </p:nvSpPr>
+        <p:spPr>
+          <a:xfrm>
+            <a:off x="7642124" y="3500287"/>
+            <a:ext cx="929146" cy="2863643"/>
+          </a:xfrm>
+          <a:prstGeom prst="rect">
+            <a:avLst/>
+          </a:prstGeom>
+        </p:spPr>
+        <p:style>
+          <a:lnRef idx="2">
+            <a:schemeClr val="accent4">
+              <a:shade val="15000"/>
+            </a:schemeClr>
+          </a:lnRef>
+          <a:fillRef idx="1">
+            <a:schemeClr val="accent4"/>
+          </a:fillRef>
+          <a:effectRef idx="0">
+            <a:schemeClr val="accent4"/>
+          </a:effectRef>
+          <a:fontRef idx="minor">
+            <a:schemeClr val="lt1"/>
+          </a:fontRef>
+        </p:style>
+        <p:txBody>
+          <a:bodyPr rtlCol="0" anchor="ctr"/>
+          <a:lstStyle/>
+          <a:p>
+            <a:pPr algn="ctr"/>
+            <a:r>
+              <a:rPr lang="en-CA" dirty="0"/>
+              <a:t>Index</a:t>
+            </a:r>
+          </a:p>
+          <a:p>
+            <a:pPr algn="ctr"/>
+            <a:r>
+              <a:rPr lang="en-CA" dirty="0"/>
+              <a:t>buffer</a:t>
+            </a:r>
+          </a:p>
+        </p:txBody>
+      </p:sp>
+      <p:sp>
+        <p:nvSpPr>
+          <p:cNvPr id="13" name="Arrow: Right 12">
+            <a:extLst>
+              <a:ext uri="{FF2B5EF4-FFF2-40B4-BE49-F238E27FC236}">
+                <a16:creationId xmlns:a16="http://schemas.microsoft.com/office/drawing/2014/main" id="{5F240329-D1AC-2AA6-9E5F-9F28FBD8DB21}"/>
+              </a:ext>
+            </a:extLst>
+          </p:cNvPr>
+          <p:cNvSpPr/>
+          <p:nvPr/>
+        </p:nvSpPr>
+        <p:spPr>
+          <a:xfrm>
+            <a:off x="8018207" y="2498626"/>
+            <a:ext cx="1470850" cy="1219200"/>
+          </a:xfrm>
+          <a:prstGeom prst="rightArrow">
+            <a:avLst/>
+          </a:prstGeom>
+        </p:spPr>
+        <p:style>
+          <a:lnRef idx="1">
+            <a:schemeClr val="accent2"/>
+          </a:lnRef>
+          <a:fillRef idx="3">
+            <a:schemeClr val="accent2"/>
+          </a:fillRef>
+          <a:effectRef idx="2">
+            <a:schemeClr val="accent2"/>
+          </a:effectRef>
+          <a:fontRef idx="minor">
+            <a:schemeClr val="lt1"/>
+          </a:fontRef>
+        </p:style>
+        <p:txBody>
+          <a:bodyPr rtlCol="0" anchor="ctr"/>
+          <a:lstStyle/>
+          <a:p>
+            <a:pPr algn="ctr"/>
+            <a:r>
+              <a:rPr lang="en-CA" dirty="0"/>
+              <a:t>Element</a:t>
+            </a:r>
+          </a:p>
+        </p:txBody>
+      </p:sp>
+      <p:sp>
+        <p:nvSpPr>
+          <p:cNvPr id="26" name="Rectangle 25">
+            <a:extLst>
+              <a:ext uri="{FF2B5EF4-FFF2-40B4-BE49-F238E27FC236}">
+                <a16:creationId xmlns:a16="http://schemas.microsoft.com/office/drawing/2014/main" id="{531FE970-6267-F244-17E0-4D3A7A538603}"/>
+              </a:ext>
+            </a:extLst>
+          </p:cNvPr>
+          <p:cNvSpPr/>
+          <p:nvPr/>
+        </p:nvSpPr>
+        <p:spPr>
+          <a:xfrm>
+            <a:off x="4602726" y="1096295"/>
+            <a:ext cx="967244" cy="1619864"/>
+          </a:xfrm>
+          <a:prstGeom prst="rect">
+            <a:avLst/>
+          </a:prstGeom>
+        </p:spPr>
+        <p:style>
+          <a:lnRef idx="1">
+            <a:schemeClr val="accent5"/>
+          </a:lnRef>
+          <a:fillRef idx="2">
+            <a:schemeClr val="accent5"/>
+          </a:fillRef>
+          <a:effectRef idx="1">
+            <a:schemeClr val="accent5"/>
+          </a:effectRef>
+          <a:fontRef idx="minor">
+            <a:schemeClr val="dk1"/>
+          </a:fontRef>
+        </p:style>
+        <p:txBody>
+          <a:bodyPr rtlCol="0" anchor="ctr"/>
+          <a:lstStyle/>
+          <a:p>
+            <a:pPr algn="ctr"/>
+            <a:r>
+              <a:rPr lang="en-CA" dirty="0"/>
+              <a:t>Verts for shader</a:t>
+            </a:r>
+          </a:p>
+        </p:txBody>
+      </p:sp>
+      <p:sp>
+        <p:nvSpPr>
+          <p:cNvPr id="20" name="Arrow: Right 19">
+            <a:extLst>
+              <a:ext uri="{FF2B5EF4-FFF2-40B4-BE49-F238E27FC236}">
+                <a16:creationId xmlns:a16="http://schemas.microsoft.com/office/drawing/2014/main" id="{9BDA74ED-B55F-4278-6F56-9A8927816E44}"/>
+              </a:ext>
+            </a:extLst>
+          </p:cNvPr>
+          <p:cNvSpPr/>
+          <p:nvPr/>
+        </p:nvSpPr>
+        <p:spPr>
+          <a:xfrm>
+            <a:off x="5444615" y="1304001"/>
+            <a:ext cx="1194623" cy="1219200"/>
+          </a:xfrm>
+          <a:prstGeom prst="rightArrow">
+            <a:avLst/>
+          </a:prstGeom>
+        </p:spPr>
+        <p:style>
+          <a:lnRef idx="1">
+            <a:schemeClr val="dk1"/>
+          </a:lnRef>
+          <a:fillRef idx="3">
+            <a:schemeClr val="dk1"/>
+          </a:fillRef>
+          <a:effectRef idx="2">
+            <a:schemeClr val="dk1"/>
+          </a:effectRef>
+          <a:fontRef idx="minor">
+            <a:schemeClr val="lt1"/>
+          </a:fontRef>
+        </p:style>
+        <p:txBody>
+          <a:bodyPr rtlCol="0" anchor="ctr"/>
+          <a:lstStyle/>
+          <a:p>
+            <a:pPr algn="ctr"/>
+            <a:endParaRPr lang="en-CA"/>
+          </a:p>
+        </p:txBody>
+      </p:sp>
+      <p:sp>
+        <p:nvSpPr>
+          <p:cNvPr id="21" name="Rectangle 20">
+            <a:extLst>
+              <a:ext uri="{FF2B5EF4-FFF2-40B4-BE49-F238E27FC236}">
+                <a16:creationId xmlns:a16="http://schemas.microsoft.com/office/drawing/2014/main" id="{77F2260F-AF25-02DA-6C74-6534CA9A5C31}"/>
+              </a:ext>
+            </a:extLst>
+          </p:cNvPr>
+          <p:cNvSpPr/>
+          <p:nvPr/>
+        </p:nvSpPr>
+        <p:spPr>
+          <a:xfrm>
+            <a:off x="2279859" y="2950920"/>
+            <a:ext cx="796409" cy="1619864"/>
+          </a:xfrm>
+          <a:prstGeom prst="rect">
+            <a:avLst/>
+          </a:prstGeom>
+        </p:spPr>
+        <p:style>
+          <a:lnRef idx="2">
+            <a:schemeClr val="accent4">
+              <a:shade val="15000"/>
+            </a:schemeClr>
+          </a:lnRef>
+          <a:fillRef idx="1">
+            <a:schemeClr val="accent4"/>
+          </a:fillRef>
+          <a:effectRef idx="0">
+            <a:schemeClr val="accent4"/>
+          </a:effectRef>
+          <a:fontRef idx="minor">
+            <a:schemeClr val="lt1"/>
+          </a:fontRef>
+        </p:style>
+        <p:txBody>
+          <a:bodyPr rtlCol="0" anchor="ctr"/>
+          <a:lstStyle/>
+          <a:p>
+            <a:pPr algn="ctr"/>
+            <a:r>
+              <a:rPr lang="en-CA" dirty="0"/>
+              <a:t>Faces</a:t>
+            </a:r>
+          </a:p>
+        </p:txBody>
+      </p:sp>
+      <p:sp>
+        <p:nvSpPr>
+          <p:cNvPr id="22" name="Arrow: Right 21">
+            <a:extLst>
+              <a:ext uri="{FF2B5EF4-FFF2-40B4-BE49-F238E27FC236}">
+                <a16:creationId xmlns:a16="http://schemas.microsoft.com/office/drawing/2014/main" id="{BD0AC423-548D-49E6-0BA5-8835D23840A3}"/>
+              </a:ext>
+            </a:extLst>
+          </p:cNvPr>
+          <p:cNvSpPr/>
+          <p:nvPr/>
+        </p:nvSpPr>
+        <p:spPr>
+          <a:xfrm>
+            <a:off x="1160200" y="2851364"/>
+            <a:ext cx="1337194" cy="1219200"/>
+          </a:xfrm>
+          <a:prstGeom prst="rightArrow">
+            <a:avLst/>
+          </a:prstGeom>
+        </p:spPr>
+        <p:style>
+          <a:lnRef idx="1">
+            <a:schemeClr val="accent2"/>
+          </a:lnRef>
+          <a:fillRef idx="3">
+            <a:schemeClr val="accent2"/>
+          </a:fillRef>
+          <a:effectRef idx="2">
+            <a:schemeClr val="accent2"/>
+          </a:effectRef>
+          <a:fontRef idx="minor">
+            <a:schemeClr val="lt1"/>
+          </a:fontRef>
+        </p:style>
+        <p:txBody>
+          <a:bodyPr rtlCol="0" anchor="ctr"/>
+          <a:lstStyle/>
+          <a:p>
+            <a:pPr algn="ctr"/>
+            <a:endParaRPr lang="en-CA"/>
+          </a:p>
+        </p:txBody>
+      </p:sp>
+      <p:sp>
+        <p:nvSpPr>
+          <p:cNvPr id="23" name="Rectangle 22">
+            <a:extLst>
+              <a:ext uri="{FF2B5EF4-FFF2-40B4-BE49-F238E27FC236}">
+                <a16:creationId xmlns:a16="http://schemas.microsoft.com/office/drawing/2014/main" id="{59F9A33C-CD3B-3F77-C781-1FEBC71F0BAA}"/>
+              </a:ext>
+            </a:extLst>
+          </p:cNvPr>
+          <p:cNvSpPr/>
+          <p:nvPr/>
+        </p:nvSpPr>
+        <p:spPr>
+          <a:xfrm>
+            <a:off x="4817198" y="2923865"/>
+            <a:ext cx="796409" cy="1619864"/>
+          </a:xfrm>
+          <a:prstGeom prst="rect">
+            <a:avLst/>
+          </a:prstGeom>
+        </p:spPr>
+        <p:style>
+          <a:lnRef idx="1">
+            <a:schemeClr val="accent5"/>
+          </a:lnRef>
+          <a:fillRef idx="2">
+            <a:schemeClr val="accent5"/>
+          </a:fillRef>
+          <a:effectRef idx="1">
+            <a:schemeClr val="accent5"/>
+          </a:effectRef>
+          <a:fontRef idx="minor">
+            <a:schemeClr val="dk1"/>
+          </a:fontRef>
+        </p:style>
+        <p:txBody>
+          <a:bodyPr rtlCol="0" anchor="ctr"/>
+          <a:lstStyle/>
+          <a:p>
+            <a:pPr algn="ctr"/>
+            <a:r>
+              <a:rPr lang="en-CA" dirty="0">
+                <a:solidFill>
+                  <a:schemeClr val="dk1"/>
+                </a:solidFill>
+              </a:rPr>
+              <a:t>Faces</a:t>
+            </a:r>
+          </a:p>
+        </p:txBody>
+      </p:sp>
+      <p:sp>
+        <p:nvSpPr>
+          <p:cNvPr id="27" name="Arrow: Right 26">
+            <a:extLst>
+              <a:ext uri="{FF2B5EF4-FFF2-40B4-BE49-F238E27FC236}">
+                <a16:creationId xmlns:a16="http://schemas.microsoft.com/office/drawing/2014/main" id="{06C8DA64-9949-999A-50FD-FF8A8D9DC974}"/>
+              </a:ext>
+            </a:extLst>
+          </p:cNvPr>
+          <p:cNvSpPr/>
+          <p:nvPr/>
+        </p:nvSpPr>
+        <p:spPr>
+          <a:xfrm>
+            <a:off x="3450829" y="3124197"/>
+            <a:ext cx="1282480" cy="1219200"/>
+          </a:xfrm>
+          <a:prstGeom prst="rightArrow">
+            <a:avLst/>
+          </a:prstGeom>
+        </p:spPr>
+        <p:style>
+          <a:lnRef idx="1">
+            <a:schemeClr val="accent2"/>
+          </a:lnRef>
+          <a:fillRef idx="3">
+            <a:schemeClr val="accent2"/>
+          </a:fillRef>
+          <a:effectRef idx="2">
+            <a:schemeClr val="accent2"/>
+          </a:effectRef>
+          <a:fontRef idx="minor">
+            <a:schemeClr val="lt1"/>
+          </a:fontRef>
+        </p:style>
+        <p:txBody>
+          <a:bodyPr rtlCol="0" anchor="ctr"/>
+          <a:lstStyle/>
+          <a:p>
+            <a:pPr algn="ctr"/>
+            <a:endParaRPr lang="en-CA" dirty="0"/>
+          </a:p>
+        </p:txBody>
+      </p:sp>
+      <p:sp>
+        <p:nvSpPr>
+          <p:cNvPr id="28" name="Arrow: Right 27">
+            <a:extLst>
+              <a:ext uri="{FF2B5EF4-FFF2-40B4-BE49-F238E27FC236}">
+                <a16:creationId xmlns:a16="http://schemas.microsoft.com/office/drawing/2014/main" id="{06E0A935-6A54-E73D-83B7-3E020F6415E0}"/>
+              </a:ext>
+            </a:extLst>
+          </p:cNvPr>
+          <p:cNvSpPr/>
+          <p:nvPr/>
+        </p:nvSpPr>
+        <p:spPr>
+          <a:xfrm rot="20419079">
+            <a:off x="5507452" y="2478819"/>
+            <a:ext cx="2482109" cy="1219200"/>
+          </a:xfrm>
+          <a:prstGeom prst="rightArrow">
+            <a:avLst/>
+          </a:prstGeom>
+        </p:spPr>
+        <p:style>
+          <a:lnRef idx="1">
+            <a:schemeClr val="dk1"/>
+          </a:lnRef>
+          <a:fillRef idx="3">
+            <a:schemeClr val="dk1"/>
+          </a:fillRef>
+          <a:effectRef idx="2">
+            <a:schemeClr val="dk1"/>
+          </a:effectRef>
+          <a:fontRef idx="minor">
+            <a:schemeClr val="lt1"/>
+          </a:fontRef>
+        </p:style>
+        <p:txBody>
+          <a:bodyPr rtlCol="0" anchor="ctr"/>
+          <a:lstStyle/>
+          <a:p>
+            <a:pPr algn="ctr"/>
+            <a:endParaRPr lang="en-CA"/>
+          </a:p>
+        </p:txBody>
+      </p:sp>
+    </p:spTree>
+    <p:extLst>
+      <p:ext uri="{BB962C8B-B14F-4D97-AF65-F5344CB8AC3E}">
+        <p14:creationId xmlns:p14="http://schemas.microsoft.com/office/powerpoint/2010/main" val="1811229887"/>
       </p:ext>
     </p:extLst>
   </p:cSld>

</xml_diff>

<commit_message>
Multiple models that can be placed
</commit_message>
<xml_diff>
--- a/Lectures/Day_02/Pipeline.pptx
+++ b/Lectures/Day_02/Pipeline.pptx
@@ -265,7 +265,7 @@
           <a:p>
             <a:fld id="{6B531558-3E01-439E-B6E2-7853B2E97E21}" type="datetimeFigureOut">
               <a:rPr lang="en-CA" smtClean="0"/>
-              <a:t>2026-05-20</a:t>
+              <a:t>2026-05-27</a:t>
             </a:fld>
             <a:endParaRPr lang="en-CA"/>
           </a:p>
@@ -465,7 +465,7 @@
           <a:p>
             <a:fld id="{6B531558-3E01-439E-B6E2-7853B2E97E21}" type="datetimeFigureOut">
               <a:rPr lang="en-CA" smtClean="0"/>
-              <a:t>2026-05-20</a:t>
+              <a:t>2026-05-27</a:t>
             </a:fld>
             <a:endParaRPr lang="en-CA"/>
           </a:p>
@@ -675,7 +675,7 @@
           <a:p>
             <a:fld id="{6B531558-3E01-439E-B6E2-7853B2E97E21}" type="datetimeFigureOut">
               <a:rPr lang="en-CA" smtClean="0"/>
-              <a:t>2026-05-20</a:t>
+              <a:t>2026-05-27</a:t>
             </a:fld>
             <a:endParaRPr lang="en-CA"/>
           </a:p>
@@ -875,7 +875,7 @@
           <a:p>
             <a:fld id="{6B531558-3E01-439E-B6E2-7853B2E97E21}" type="datetimeFigureOut">
               <a:rPr lang="en-CA" smtClean="0"/>
-              <a:t>2026-05-20</a:t>
+              <a:t>2026-05-27</a:t>
             </a:fld>
             <a:endParaRPr lang="en-CA"/>
           </a:p>
@@ -1151,7 +1151,7 @@
           <a:p>
             <a:fld id="{6B531558-3E01-439E-B6E2-7853B2E97E21}" type="datetimeFigureOut">
               <a:rPr lang="en-CA" smtClean="0"/>
-              <a:t>2026-05-20</a:t>
+              <a:t>2026-05-27</a:t>
             </a:fld>
             <a:endParaRPr lang="en-CA"/>
           </a:p>
@@ -1419,7 +1419,7 @@
           <a:p>
             <a:fld id="{6B531558-3E01-439E-B6E2-7853B2E97E21}" type="datetimeFigureOut">
               <a:rPr lang="en-CA" smtClean="0"/>
-              <a:t>2026-05-20</a:t>
+              <a:t>2026-05-27</a:t>
             </a:fld>
             <a:endParaRPr lang="en-CA"/>
           </a:p>
@@ -1834,7 +1834,7 @@
           <a:p>
             <a:fld id="{6B531558-3E01-439E-B6E2-7853B2E97E21}" type="datetimeFigureOut">
               <a:rPr lang="en-CA" smtClean="0"/>
-              <a:t>2026-05-20</a:t>
+              <a:t>2026-05-27</a:t>
             </a:fld>
             <a:endParaRPr lang="en-CA"/>
           </a:p>
@@ -1976,7 +1976,7 @@
           <a:p>
             <a:fld id="{6B531558-3E01-439E-B6E2-7853B2E97E21}" type="datetimeFigureOut">
               <a:rPr lang="en-CA" smtClean="0"/>
-              <a:t>2026-05-20</a:t>
+              <a:t>2026-05-27</a:t>
             </a:fld>
             <a:endParaRPr lang="en-CA"/>
           </a:p>
@@ -2089,7 +2089,7 @@
           <a:p>
             <a:fld id="{6B531558-3E01-439E-B6E2-7853B2E97E21}" type="datetimeFigureOut">
               <a:rPr lang="en-CA" smtClean="0"/>
-              <a:t>2026-05-20</a:t>
+              <a:t>2026-05-27</a:t>
             </a:fld>
             <a:endParaRPr lang="en-CA"/>
           </a:p>
@@ -2402,7 +2402,7 @@
           <a:p>
             <a:fld id="{6B531558-3E01-439E-B6E2-7853B2E97E21}" type="datetimeFigureOut">
               <a:rPr lang="en-CA" smtClean="0"/>
-              <a:t>2026-05-20</a:t>
+              <a:t>2026-05-27</a:t>
             </a:fld>
             <a:endParaRPr lang="en-CA"/>
           </a:p>
@@ -2691,7 +2691,7 @@
           <a:p>
             <a:fld id="{6B531558-3E01-439E-B6E2-7853B2E97E21}" type="datetimeFigureOut">
               <a:rPr lang="en-CA" smtClean="0"/>
-              <a:t>2026-05-20</a:t>
+              <a:t>2026-05-27</a:t>
             </a:fld>
             <a:endParaRPr lang="en-CA"/>
           </a:p>
@@ -2934,7 +2934,7 @@
           <a:p>
             <a:fld id="{6B531558-3E01-439E-B6E2-7853B2E97E21}" type="datetimeFigureOut">
               <a:rPr lang="en-CA" smtClean="0"/>
-              <a:t>2026-05-20</a:t>
+              <a:t>2026-05-27</a:t>
             </a:fld>
             <a:endParaRPr lang="en-CA"/>
           </a:p>
@@ -3482,7 +3482,7 @@
         </p:nvSpPr>
         <p:spPr>
           <a:xfrm>
-            <a:off x="3165378" y="1487131"/>
+            <a:off x="3853022" y="1487131"/>
             <a:ext cx="669819" cy="3962400"/>
           </a:xfrm>
           <a:prstGeom prst="rect">
@@ -3646,7 +3646,7 @@
         </p:nvSpPr>
         <p:spPr>
           <a:xfrm>
-            <a:off x="6400803" y="1632155"/>
+            <a:off x="6400802" y="1622323"/>
             <a:ext cx="929146" cy="3962400"/>
           </a:xfrm>
           <a:prstGeom prst="rect">
@@ -3700,8 +3700,8 @@
         </p:nvSpPr>
         <p:spPr>
           <a:xfrm>
-            <a:off x="4100667" y="2998839"/>
-            <a:ext cx="2167397" cy="1219200"/>
+            <a:off x="4423295" y="2998839"/>
+            <a:ext cx="1844769" cy="1219200"/>
           </a:xfrm>
           <a:prstGeom prst="rightArrow">
             <a:avLst/>
@@ -4096,6 +4096,53 @@
           <a:p>
             <a:pPr algn="ctr"/>
             <a:endParaRPr lang="en-CA"/>
+          </a:p>
+        </p:txBody>
+      </p:sp>
+      <p:sp>
+        <p:nvSpPr>
+          <p:cNvPr id="2" name="Rectangle 1">
+            <a:extLst>
+              <a:ext uri="{FF2B5EF4-FFF2-40B4-BE49-F238E27FC236}">
+                <a16:creationId xmlns:a16="http://schemas.microsoft.com/office/drawing/2014/main" id="{EDBED69B-7ED3-EED6-F182-BA52223C380F}"/>
+              </a:ext>
+            </a:extLst>
+          </p:cNvPr>
+          <p:cNvSpPr/>
+          <p:nvPr/>
+        </p:nvSpPr>
+        <p:spPr>
+          <a:xfrm>
+            <a:off x="2791138" y="1543666"/>
+            <a:ext cx="669819" cy="3962400"/>
+          </a:xfrm>
+          <a:prstGeom prst="rect">
+            <a:avLst/>
+          </a:prstGeom>
+        </p:spPr>
+        <p:style>
+          <a:lnRef idx="3">
+            <a:schemeClr val="lt1"/>
+          </a:lnRef>
+          <a:fillRef idx="1">
+            <a:schemeClr val="accent6"/>
+          </a:fillRef>
+          <a:effectRef idx="1">
+            <a:schemeClr val="accent6"/>
+          </a:effectRef>
+          <a:fontRef idx="minor">
+            <a:schemeClr val="lt1"/>
+          </a:fontRef>
+        </p:style>
+        <p:txBody>
+          <a:bodyPr rtlCol="0" anchor="ctr"/>
+          <a:lstStyle/>
+          <a:p>
+            <a:pPr algn="ctr"/>
+            <a:r>
+              <a:rPr lang="en-CA" dirty="0"/>
+              <a:t>RAM</a:t>
+            </a:r>
           </a:p>
         </p:txBody>
       </p:sp>

</xml_diff>